<commit_message>
Presentation : slide acces en ligne (liens) + captures pipeline/MLflow/Swagger
</commit_message>
<xml_diff>
--- a/05_LIVRABLES/presentation/Presentation_Teranga_Market.pptx
+++ b/05_LIVRABLES/presentation/Presentation_Teranga_Market.pptx
@@ -4,9 +4,6 @@
   <p:sldMasterIdLst>
     <p:sldMasterId id="2147483648" r:id="rId1"/>
   </p:sldMasterIdLst>
-  <p:notesMasterIdLst>
-    <p:notesMasterId r:id="rId15"/>
-  </p:notesMasterIdLst>
   <p:sldIdLst>
     <p:sldId id="256" r:id="rId2"/>
     <p:sldId id="257" r:id="rId3"/>
@@ -21,7 +18,12 @@
     <p:sldId id="266" r:id="rId12"/>
     <p:sldId id="267" r:id="rId13"/>
     <p:sldId id="268" r:id="rId14"/>
+    <p:sldId id="269" r:id="rId15"/>
+    <p:sldId id="270" r:id="rId16"/>
   </p:sldIdLst>
+  <p:notesMasterIdLst>
+    <p:notesMasterId r:id="rId17"/>
+  </p:notesMasterIdLst>
   <p:sldSz cx="12192000" cy="6858000"/>
   <p:notesSz cx="6858000" cy="12192000"/>
   <p:defaultTextStyle>
@@ -116,20 +118,13 @@
       </a:defRPr>
     </a:lvl9pPr>
   </p:defaultTextStyle>
-  <p:extLst>
-    <p:ext uri="{EFAFB233-063F-42B5-8137-9DF3F51BA10A}">
-      <p15:sldGuideLst xmlns:p15="http://schemas.microsoft.com/office/powerpoint/2012/main"/>
-    </p:ext>
-  </p:extLst>
 </p:presentation>
 </file>
 
 <file path=ppt/charts/chart1.xml><?xml version="1.0" encoding="utf-8"?>
-<c:chartSpace xmlns:c="http://schemas.openxmlformats.org/drawingml/2006/chart" xmlns:a="http://schemas.openxmlformats.org/drawingml/2006/main" xmlns:r="http://schemas.openxmlformats.org/officeDocument/2006/relationships" xmlns:c16r2="http://schemas.microsoft.com/office/drawing/2015/06/chart">
+<c:chartSpace xmlns:c="http://schemas.openxmlformats.org/drawingml/2006/chart" xmlns:a="http://schemas.openxmlformats.org/drawingml/2006/main" xmlns:r="http://schemas.openxmlformats.org/officeDocument/2006/relationships">
   <c:date1904 val="0"/>
-  <c:lang val="fr-FR"/>
   <c:roundedCorners val="1"/>
-  <c:style val="2"/>
   <c:chart>
     <c:title>
       <c:tx>
@@ -146,7 +141,7 @@
               </a:defRPr>
             </a:pPr>
             <a:r>
-              <a:rPr lang="fr-FR" sz="1400" b="0" i="0" u="none" strike="noStrike">
+              <a:rPr sz="1400" b="0" i="0" u="none" strike="noStrike">
                 <a:solidFill>
                   <a:srgbClr val="003B7A"/>
                 </a:solidFill>
@@ -157,6 +152,7 @@
           </a:p>
         </c:rich>
       </c:tx>
+      <c:layout/>
       <c:overlay val="0"/>
     </c:title>
     <c:autoTitleDeleted val="0"/>
@@ -189,26 +185,18 @@
           <c:invertIfNegative val="0"/>
           <c:dLbls>
             <c:numFmt formatCode="#,##0" sourceLinked="0"/>
-            <c:spPr>
-              <a:noFill/>
-              <a:ln>
-                <a:noFill/>
-              </a:ln>
-              <a:effectLst/>
-            </c:spPr>
             <c:txPr>
               <a:bodyPr/>
               <a:lstStyle/>
               <a:p>
                 <a:pPr>
-                  <a:defRPr sz="1300" b="0" i="0" u="none" strike="noStrike">
+                  <a:defRPr b="0" i="0" strike="noStrike" sz="1300" u="none">
                     <a:solidFill>
                       <a:srgbClr val="1B2A3A"/>
                     </a:solidFill>
                     <a:latin typeface="Calibri"/>
                   </a:defRPr>
                 </a:pPr>
-                <a:endParaRPr lang="fr-FR"/>
               </a:p>
             </c:txPr>
             <c:showLegendKey val="0"/>
@@ -218,28 +206,25 @@
             <c:showPercent val="0"/>
             <c:showBubbleSize val="0"/>
             <c:showLeaderLines val="0"/>
-            <c:extLst>
-              <c:ext xmlns:c15="http://schemas.microsoft.com/office/drawing/2012/chart" uri="{CE6537A1-D6FC-4f65-9D91-7224C49458BB}">
-                <c15:showLeaderLines val="0"/>
-              </c:ext>
-            </c:extLst>
           </c:dLbls>
           <c:cat>
-            <c:strRef>
+            <c:multiLvlStrRef>
               <c:f>Sheet1!$A$2:$A$4</c:f>
-              <c:strCache>
+              <c:multiLvlStrCache>
                 <c:ptCount val="3"/>
-                <c:pt idx="0">
-                  <c:v>Baseline naïf</c:v>
-                </c:pt>
-                <c:pt idx="1">
-                  <c:v>Prophet</c:v>
-                </c:pt>
-                <c:pt idx="2">
-                  <c:v>Prophet + promo</c:v>
-                </c:pt>
-              </c:strCache>
-            </c:strRef>
+                <c:lvl>
+                  <c:pt idx="0">
+                    <c:v>Baseline naïf</c:v>
+                  </c:pt>
+                  <c:pt idx="1">
+                    <c:v>Prophet</c:v>
+                  </c:pt>
+                  <c:pt idx="2">
+                    <c:v>Prophet + promo</c:v>
+                  </c:pt>
+                </c:lvl>
+              </c:multiLvlStrCache>
+            </c:multiLvlStrRef>
           </c:cat>
           <c:val>
             <c:numRef>
@@ -248,34 +233,47 @@
                 <c:formatCode>General</c:formatCode>
                 <c:ptCount val="3"/>
                 <c:pt idx="0">
-                  <c:v>65.900000000000006</c:v>
+                  <c:v>65.9</c:v>
                 </c:pt>
                 <c:pt idx="1">
                   <c:v>43.5</c:v>
                 </c:pt>
                 <c:pt idx="2">
-                  <c:v>37.299999999999997</c:v>
+                  <c:v>37.3</c:v>
                 </c:pt>
               </c:numCache>
             </c:numRef>
           </c:val>
-          <c:extLst>
-            <c:ext xmlns:c16="http://schemas.microsoft.com/office/drawing/2014/chart" uri="{C3380CC4-5D6E-409C-BE32-E72D297353CC}">
-              <c16:uniqueId val="{00000000-4A0A-479A-97F9-4E90CC9FB259}"/>
-            </c:ext>
-          </c:extLst>
         </c:ser>
         <c:dLbls>
+          <c:numFmt formatCode="#,##0" sourceLinked="0"/>
+          <c:txPr>
+            <a:bodyPr/>
+            <a:lstStyle/>
+            <a:p>
+              <a:pPr>
+                <a:defRPr b="0" i="0" strike="noStrike" sz="1300" u="none">
+                  <a:solidFill>
+                    <a:srgbClr val="1B2A3A"/>
+                  </a:solidFill>
+                  <a:latin typeface="Calibri"/>
+                </a:defRPr>
+              </a:pPr>
+            </a:p>
+          </c:txPr>
           <c:showLegendKey val="0"/>
           <c:showVal val="1"/>
           <c:showCatName val="0"/>
           <c:showSerName val="0"/>
           <c:showPercent val="0"/>
           <c:showBubbleSize val="0"/>
+          <c:showLeaderLines val="0"/>
         </c:dLbls>
         <c:gapWidth val="150"/>
+        <c:overlap val="0"/>
         <c:axId val="2094734554"/>
         <c:axId val="2094734552"/>
+        <c:axId val="2094734556"/>
       </c:barChart>
       <c:catAx>
         <c:axId val="2094734554"/>
@@ -316,7 +314,6 @@
         <c:crosses val="autoZero"/>
         <c:auto val="1"/>
         <c:lblAlgn val="ctr"/>
-        <c:lblOffset val="100"/>
         <c:noMultiLvlLbl val="1"/>
       </c:catAx>
       <c:valAx>
@@ -379,7 +376,6 @@
     </c:plotArea>
     <c:plotVisOnly val="1"/>
     <c:dispBlanksAs val="span"/>
-    <c:showDLblsOverMax val="1"/>
   </c:chart>
   <c:spPr>
     <a:noFill/>
@@ -395,11 +391,9 @@
 </file>
 
 <file path=ppt/charts/chart2.xml><?xml version="1.0" encoding="utf-8"?>
-<c:chartSpace xmlns:c="http://schemas.openxmlformats.org/drawingml/2006/chart" xmlns:a="http://schemas.openxmlformats.org/drawingml/2006/main" xmlns:r="http://schemas.openxmlformats.org/officeDocument/2006/relationships" xmlns:c16r2="http://schemas.microsoft.com/office/drawing/2015/06/chart">
+<c:chartSpace xmlns:c="http://schemas.openxmlformats.org/drawingml/2006/chart" xmlns:a="http://schemas.openxmlformats.org/drawingml/2006/main" xmlns:r="http://schemas.openxmlformats.org/officeDocument/2006/relationships">
   <c:date1904 val="0"/>
-  <c:lang val="fr-FR"/>
   <c:roundedCorners val="1"/>
-  <c:style val="2"/>
   <c:chart>
     <c:autoTitleDeleted val="1"/>
     <c:plotArea>
@@ -431,26 +425,18 @@
           <c:invertIfNegative val="0"/>
           <c:dLbls>
             <c:numFmt formatCode="#,##0" sourceLinked="0"/>
-            <c:spPr>
-              <a:noFill/>
-              <a:ln>
-                <a:noFill/>
-              </a:ln>
-              <a:effectLst/>
-            </c:spPr>
             <c:txPr>
               <a:bodyPr/>
               <a:lstStyle/>
               <a:p>
                 <a:pPr>
-                  <a:defRPr sz="1300" b="0" i="0" u="none" strike="noStrike">
+                  <a:defRPr b="0" i="0" strike="noStrike" sz="1300" u="none">
                     <a:solidFill>
                       <a:srgbClr val="1B2A3A"/>
                     </a:solidFill>
                     <a:latin typeface="Calibri"/>
                   </a:defRPr>
                 </a:pPr>
-                <a:endParaRPr lang="fr-FR"/>
               </a:p>
             </c:txPr>
             <c:showLegendKey val="0"/>
@@ -460,34 +446,31 @@
             <c:showPercent val="0"/>
             <c:showBubbleSize val="0"/>
             <c:showLeaderLines val="0"/>
-            <c:extLst>
-              <c:ext xmlns:c15="http://schemas.microsoft.com/office/drawing/2012/chart" uri="{CE6537A1-D6FC-4f65-9D91-7224C49458BB}">
-                <c15:showLeaderLines val="0"/>
-              </c:ext>
-            </c:extLst>
           </c:dLbls>
           <c:cat>
-            <c:strRef>
+            <c:multiLvlStrRef>
               <c:f>Sheet1!$A$2:$A$6</c:f>
-              <c:strCache>
+              <c:multiLvlStrCache>
                 <c:ptCount val="5"/>
-                <c:pt idx="0">
-                  <c:v>Hasard</c:v>
-                </c:pt>
-                <c:pt idx="1">
-                  <c:v>Populaire</c:v>
-                </c:pt>
-                <c:pt idx="2">
-                  <c:v>Content</c:v>
-                </c:pt>
-                <c:pt idx="3">
-                  <c:v>Collaboratif</c:v>
-                </c:pt>
-                <c:pt idx="4">
-                  <c:v>Hybride</c:v>
-                </c:pt>
-              </c:strCache>
-            </c:strRef>
+                <c:lvl>
+                  <c:pt idx="0">
+                    <c:v>Hasard</c:v>
+                  </c:pt>
+                  <c:pt idx="1">
+                    <c:v>Populaire</c:v>
+                  </c:pt>
+                  <c:pt idx="2">
+                    <c:v>Content</c:v>
+                  </c:pt>
+                  <c:pt idx="3">
+                    <c:v>Collaboratif</c:v>
+                  </c:pt>
+                  <c:pt idx="4">
+                    <c:v>Hybride</c:v>
+                  </c:pt>
+                </c:lvl>
+              </c:multiLvlStrCache>
+            </c:multiLvlStrRef>
           </c:cat>
           <c:val>
             <c:numRef>
@@ -513,23 +496,36 @@
               </c:numCache>
             </c:numRef>
           </c:val>
-          <c:extLst>
-            <c:ext xmlns:c16="http://schemas.microsoft.com/office/drawing/2014/chart" uri="{C3380CC4-5D6E-409C-BE32-E72D297353CC}">
-              <c16:uniqueId val="{00000000-695D-476F-9C9A-18C6B5FEB59A}"/>
-            </c:ext>
-          </c:extLst>
         </c:ser>
         <c:dLbls>
+          <c:numFmt formatCode="#,##0" sourceLinked="0"/>
+          <c:txPr>
+            <a:bodyPr/>
+            <a:lstStyle/>
+            <a:p>
+              <a:pPr>
+                <a:defRPr b="0" i="0" strike="noStrike" sz="1300" u="none">
+                  <a:solidFill>
+                    <a:srgbClr val="1B2A3A"/>
+                  </a:solidFill>
+                  <a:latin typeface="Calibri"/>
+                </a:defRPr>
+              </a:pPr>
+            </a:p>
+          </c:txPr>
           <c:showLegendKey val="0"/>
           <c:showVal val="1"/>
           <c:showCatName val="0"/>
           <c:showSerName val="0"/>
           <c:showPercent val="0"/>
           <c:showBubbleSize val="0"/>
+          <c:showLeaderLines val="0"/>
         </c:dLbls>
         <c:gapWidth val="150"/>
+        <c:overlap val="0"/>
         <c:axId val="2094734554"/>
         <c:axId val="2094734552"/>
+        <c:axId val="2094734556"/>
       </c:barChart>
       <c:catAx>
         <c:axId val="2094734554"/>
@@ -570,7 +566,6 @@
         <c:crosses val="autoZero"/>
         <c:auto val="1"/>
         <c:lblAlgn val="ctr"/>
-        <c:lblOffset val="100"/>
         <c:noMultiLvlLbl val="1"/>
       </c:catAx>
       <c:valAx>
@@ -633,7 +628,6 @@
     </c:plotArea>
     <c:plotVisOnly val="1"/>
     <c:dispBlanksAs val="span"/>
-    <c:showDLblsOverMax val="1"/>
   </c:chart>
   <c:spPr>
     <a:noFill/>
@@ -670,10 +664,234 @@
           <a:chExt cx="0" cy="0"/>
         </a:xfrm>
       </p:grpSpPr>
+      <p:sp>
+        <p:nvSpPr>
+          <p:cNvPr id="2" name="Header Placeholder 1"/>
+          <p:cNvSpPr>
+            <a:spLocks noGrp="1"/>
+          </p:cNvSpPr>
+          <p:nvPr>
+            <p:ph type="hdr" sz="quarter"/>
+          </p:nvPr>
+        </p:nvSpPr>
+        <p:spPr>
+          <a:xfrm>
+            <a:off x="0" y="0"/>
+            <a:ext cx="2971800" cy="458788"/>
+          </a:xfrm>
+          <a:prstGeom prst="rect">
+            <a:avLst/>
+          </a:prstGeom>
+        </p:spPr>
+        <p:txBody>
+          <a:bodyPr vert="horz" lIns="91440" tIns="45720" rIns="91440" bIns="45720" rtlCol="0"/>
+          <a:lstStyle>
+            <a:lvl1pPr algn="l">
+              <a:defRPr sz="1200"/>
+            </a:lvl1pPr>
+          </a:lstStyle>
+          <a:p>
+            <a:endParaRPr lang="en-US"/>
+          </a:p>
+        </p:txBody>
+      </p:sp>
+      <p:sp>
+        <p:nvSpPr>
+          <p:cNvPr id="3" name="Date Placeholder 2"/>
+          <p:cNvSpPr>
+            <a:spLocks noGrp="1"/>
+          </p:cNvSpPr>
+          <p:nvPr>
+            <p:ph type="dt" idx="1"/>
+          </p:nvPr>
+        </p:nvSpPr>
+        <p:spPr>
+          <a:xfrm>
+            <a:off x="3884613" y="0"/>
+            <a:ext cx="2971800" cy="458788"/>
+          </a:xfrm>
+          <a:prstGeom prst="rect">
+            <a:avLst/>
+          </a:prstGeom>
+        </p:spPr>
+        <p:txBody>
+          <a:bodyPr vert="horz" lIns="91440" tIns="45720" rIns="91440" bIns="45720" rtlCol="0"/>
+          <a:lstStyle>
+            <a:lvl1pPr algn="r">
+              <a:defRPr sz="1200"/>
+            </a:lvl1pPr>
+          </a:lstStyle>
+          <a:p>
+            <a:fld id="{5282F153-3F37-0F45-9E97-73ACFA13230C}" type="datetimeFigureOut">
+              <a:rPr lang="en-US"/>
+              <a:t>7/23/19</a:t>
+            </a:fld>
+            <a:endParaRPr lang="en-US"/>
+          </a:p>
+        </p:txBody>
+      </p:sp>
+      <p:sp>
+        <p:nvSpPr>
+          <p:cNvPr id="4" name="Slide Image Placeholder 3"/>
+          <p:cNvSpPr>
+            <a:spLocks noGrp="1" noRot="1" noChangeAspect="1"/>
+          </p:cNvSpPr>
+          <p:nvPr>
+            <p:ph type="sldImg" idx="2"/>
+          </p:nvPr>
+        </p:nvSpPr>
+        <p:spPr>
+          <a:xfrm>
+            <a:off x="685800" y="1143000"/>
+            <a:ext cx="5486400" cy="3086100"/>
+          </a:xfrm>
+          <a:prstGeom prst="rect">
+            <a:avLst/>
+          </a:prstGeom>
+          <a:noFill/>
+          <a:ln w="12700">
+            <a:solidFill>
+              <a:prstClr val="black"/>
+            </a:solidFill>
+          </a:ln>
+        </p:spPr>
+        <p:txBody>
+          <a:bodyPr vert="horz" lIns="91440" tIns="45720" rIns="91440" bIns="45720" rtlCol="0" anchor="ctr"/>
+          <a:lstStyle/>
+          <a:p>
+            <a:endParaRPr lang="en-US"/>
+          </a:p>
+        </p:txBody>
+      </p:sp>
+      <p:sp>
+        <p:nvSpPr>
+          <p:cNvPr id="5" name="Notes Placeholder 4"/>
+          <p:cNvSpPr>
+            <a:spLocks noGrp="1"/>
+          </p:cNvSpPr>
+          <p:nvPr>
+            <p:ph type="body" sz="quarter" idx="3"/>
+          </p:nvPr>
+        </p:nvSpPr>
+        <p:spPr>
+          <a:xfrm>
+            <a:off x="685800" y="4400550"/>
+            <a:ext cx="5486400" cy="3600450"/>
+          </a:xfrm>
+          <a:prstGeom prst="rect">
+            <a:avLst/>
+          </a:prstGeom>
+        </p:spPr>
+        <p:txBody>
+          <a:bodyPr vert="horz" lIns="91440" tIns="45720" rIns="91440" bIns="45720" rtlCol="0"/>
+          <a:lstStyle/>
+          <a:p>
+            <a:pPr lvl="0"/>
+            <a:r>
+              <a:rPr lang="en-US"/>
+              <a:t>Click to edit Master text styles</a:t>
+            </a:r>
+          </a:p>
+          <a:p>
+            <a:pPr lvl="1"/>
+            <a:r>
+              <a:rPr lang="en-US"/>
+              <a:t>Second level</a:t>
+            </a:r>
+          </a:p>
+          <a:p>
+            <a:pPr lvl="2"/>
+            <a:r>
+              <a:rPr lang="en-US"/>
+              <a:t>Third level</a:t>
+            </a:r>
+          </a:p>
+          <a:p>
+            <a:pPr lvl="3"/>
+            <a:r>
+              <a:rPr lang="en-US"/>
+              <a:t>Fourth level</a:t>
+            </a:r>
+          </a:p>
+          <a:p>
+            <a:pPr lvl="4"/>
+            <a:r>
+              <a:rPr lang="en-US"/>
+              <a:t>Fifth level</a:t>
+            </a:r>
+          </a:p>
+        </p:txBody>
+      </p:sp>
+      <p:sp>
+        <p:nvSpPr>
+          <p:cNvPr id="6" name="Footer Placeholder 5"/>
+          <p:cNvSpPr>
+            <a:spLocks noGrp="1"/>
+          </p:cNvSpPr>
+          <p:nvPr>
+            <p:ph type="ftr" sz="quarter" idx="4"/>
+          </p:nvPr>
+        </p:nvSpPr>
+        <p:spPr>
+          <a:xfrm>
+            <a:off x="0" y="8685213"/>
+            <a:ext cx="2971800" cy="458787"/>
+          </a:xfrm>
+          <a:prstGeom prst="rect">
+            <a:avLst/>
+          </a:prstGeom>
+        </p:spPr>
+        <p:txBody>
+          <a:bodyPr vert="horz" lIns="91440" tIns="45720" rIns="91440" bIns="45720" rtlCol="0" anchor="b"/>
+          <a:lstStyle>
+            <a:lvl1pPr algn="l">
+              <a:defRPr sz="1200"/>
+            </a:lvl1pPr>
+          </a:lstStyle>
+          <a:p>
+            <a:endParaRPr lang="en-US"/>
+          </a:p>
+        </p:txBody>
+      </p:sp>
+      <p:sp>
+        <p:nvSpPr>
+          <p:cNvPr id="7" name="Slide Number Placeholder 6"/>
+          <p:cNvSpPr>
+            <a:spLocks noGrp="1"/>
+          </p:cNvSpPr>
+          <p:nvPr>
+            <p:ph type="sldNum" sz="quarter" idx="5"/>
+          </p:nvPr>
+        </p:nvSpPr>
+        <p:spPr>
+          <a:xfrm>
+            <a:off x="3884613" y="8685213"/>
+            <a:ext cx="2971800" cy="458787"/>
+          </a:xfrm>
+          <a:prstGeom prst="rect">
+            <a:avLst/>
+          </a:prstGeom>
+        </p:spPr>
+        <p:txBody>
+          <a:bodyPr vert="horz" lIns="91440" tIns="45720" rIns="91440" bIns="45720" rtlCol="0" anchor="b"/>
+          <a:lstStyle>
+            <a:lvl1pPr algn="r">
+              <a:defRPr sz="1200"/>
+            </a:lvl1pPr>
+          </a:lstStyle>
+          <a:p>
+            <a:fld id="{CE5E9CC1-C706-0F49-92D6-E571CC5EEA8F}" type="slidenum">
+              <a:rPr lang="en-US"/>
+              <a:t>‹#›</a:t>
+            </a:fld>
+            <a:endParaRPr lang="en-US"/>
+          </a:p>
+        </p:txBody>
+      </p:sp>
     </p:spTree>
     <p:extLst>
       <p:ext uri="{BB962C8B-B14F-4D97-AF65-F5344CB8AC3E}">
-        <p14:creationId xmlns:p14="http://schemas.microsoft.com/office/powerpoint/2010/main" val="3973965475"/>
+        <p14:creationId xmlns:p14="http://schemas.microsoft.com/office/powerpoint/2010/main" val="1024086991"/>
       </p:ext>
     </p:extLst>
   </p:cSld>
@@ -821,6 +1039,7 @@
               <a:rPr lang="en-US" dirty="0"/>
               <a:t>Bonjour, nous présentons la plateforme data-driven conçue pour Teranga Market : prévision, pricing et recommandation, de la donnée jusqu'à la décision.</a:t>
             </a:r>
+            <a:endParaRPr lang="en-US" dirty="0"/>
           </a:p>
         </p:txBody>
       </p:sp>
@@ -908,6 +1127,7 @@
               <a:rPr lang="en-US" dirty="0"/>
               <a:t>635 M/an de bénéfice potentiel pour 36 M/an de coûts : ROI très favorable. Ce sont des montants en régime établi, atteints progressivement.</a:t>
             </a:r>
+            <a:endParaRPr lang="en-US" dirty="0"/>
           </a:p>
         </p:txBody>
       </p:sp>
@@ -993,8 +1213,9 @@
           <a:p>
             <a:r>
               <a:rPr lang="en-US" dirty="0"/>
-              <a:t>Trame de démo : 1) lancer l'API puis le dashboard ; 2) montrer les KPIs ; 3) jouer avec le simulateur de prix ; 4) montrer la couverture de stock ; 5) faire une reco en direct via l'API. Bien lancer les 2 terminaux AVANT la soutenance.</a:t>
-            </a:r>
+              <a:t>Le projet est déployé : dashboard + API cliquables. Sans démo live, le prof teste tout via ces 2 liens. Airflow et MLflow restent en local (captures suivantes). Démo dashboard : KPIs → simulateur de prix → couverture de stock → reco en direct.</a:t>
+            </a:r>
+            <a:endParaRPr lang="en-US" dirty="0"/>
           </a:p>
         </p:txBody>
       </p:sp>
@@ -1080,8 +1301,9 @@
           <a:p>
             <a:r>
               <a:rPr lang="en-US" dirty="0"/>
-              <a:t>En conclusion : la chaîne marche de bout en bout, la valeur est démontrée, on recommande un déploiement progressif.</a:t>
-            </a:r>
+              <a:t>Pipeline orchestré par Airflow (Docker). Les 4 tâches s'enchaînent, toutes en succès. Exécutable en local.</a:t>
+            </a:r>
+            <a:endParaRPr lang="en-US" dirty="0"/>
           </a:p>
         </p:txBody>
       </p:sp>
@@ -1167,8 +1389,9 @@
           <a:p>
             <a:r>
               <a:rPr lang="en-US" dirty="0"/>
-              <a:t>Merci — nous sommes prêts pour vos questions.</a:t>
-            </a:r>
+              <a:t>MLflow trace chaque modèle : paramètres, métriques, versions — le cœur du MLOps (reproductibilité, suivi). Exécutable en local via mlflow ui.</a:t>
+            </a:r>
+            <a:endParaRPr lang="en-US" dirty="0"/>
           </a:p>
         </p:txBody>
       </p:sp>
@@ -1190,6 +1413,182 @@
             <a:fld id="{F7021451-1387-4CA6-816F-3879F97B5CBC}" type="slidenum">
               <a:rPr lang="en-US"/>
               <a:t>13</a:t>
+            </a:fld>
+            <a:endParaRPr lang="en-US"/>
+          </a:p>
+        </p:txBody>
+      </p:sp>
+    </p:spTree>
+    <p:extLst>
+      <p:ext uri="{BB962C8B-B14F-4D97-AF65-F5344CB8AC3E}">
+        <p14:creationId xmlns:p14="http://schemas.microsoft.com/office/powerpoint/2010/main" val="1024086991"/>
+      </p:ext>
+    </p:extLst>
+  </p:cSld>
+  <p:clrMapOvr>
+    <a:masterClrMapping/>
+  </p:clrMapOvr>
+</p:notes>
+</file>
+
+<file path=ppt/notesSlides/notesSlide14.xml><?xml version="1.0" encoding="utf-8"?>
+<p:notes xmlns:a="http://schemas.openxmlformats.org/drawingml/2006/main" xmlns:r="http://schemas.openxmlformats.org/officeDocument/2006/relationships" xmlns:p="http://schemas.openxmlformats.org/presentationml/2006/main">
+  <p:cSld>
+    <p:spTree>
+      <p:nvGrpSpPr>
+        <p:cNvPr id="1" name=""/>
+        <p:cNvGrpSpPr/>
+        <p:nvPr/>
+      </p:nvGrpSpPr>
+      <p:grpSpPr>
+        <a:xfrm>
+          <a:off x="0" y="0"/>
+          <a:ext cx="0" cy="0"/>
+          <a:chOff x="0" y="0"/>
+          <a:chExt cx="0" cy="0"/>
+        </a:xfrm>
+      </p:grpSpPr>
+      <p:sp>
+        <p:nvSpPr>
+          <p:cNvPr id="2" name="Slide Image Placeholder 1"/>
+          <p:cNvSpPr>
+            <a:spLocks noGrp="1" noRot="1" noChangeAspect="1"/>
+          </p:cNvSpPr>
+          <p:nvPr>
+            <p:ph type="sldImg"/>
+          </p:nvPr>
+        </p:nvSpPr>
+        <p:spPr/>
+      </p:sp>
+      <p:sp>
+        <p:nvSpPr>
+          <p:cNvPr id="3" name="Notes Placeholder 2"/>
+          <p:cNvSpPr>
+            <a:spLocks noGrp="1"/>
+          </p:cNvSpPr>
+          <p:nvPr>
+            <p:ph type="body" idx="1"/>
+          </p:nvPr>
+        </p:nvSpPr>
+        <p:spPr/>
+        <p:txBody>
+          <a:bodyPr/>
+          <a:lstStyle/>
+          <a:p>
+            <a:r>
+              <a:rPr lang="en-US" dirty="0"/>
+              <a:t>En conclusion : la chaîne marche de bout en bout, la valeur est démontrée, on recommande un déploiement progressif.</a:t>
+            </a:r>
+            <a:endParaRPr lang="en-US" dirty="0"/>
+          </a:p>
+        </p:txBody>
+      </p:sp>
+      <p:sp>
+        <p:nvSpPr>
+          <p:cNvPr id="4" name="Slide Number Placeholder 3"/>
+          <p:cNvSpPr>
+            <a:spLocks noGrp="1"/>
+          </p:cNvSpPr>
+          <p:nvPr>
+            <p:ph type="sldNum" sz="quarter" idx="10"/>
+          </p:nvPr>
+        </p:nvSpPr>
+        <p:spPr/>
+        <p:txBody>
+          <a:bodyPr/>
+          <a:lstStyle/>
+          <a:p>
+            <a:fld id="{F7021451-1387-4CA6-816F-3879F97B5CBC}" type="slidenum">
+              <a:rPr lang="en-US"/>
+              <a:t>14</a:t>
+            </a:fld>
+            <a:endParaRPr lang="en-US"/>
+          </a:p>
+        </p:txBody>
+      </p:sp>
+    </p:spTree>
+    <p:extLst>
+      <p:ext uri="{BB962C8B-B14F-4D97-AF65-F5344CB8AC3E}">
+        <p14:creationId xmlns:p14="http://schemas.microsoft.com/office/powerpoint/2010/main" val="1024086991"/>
+      </p:ext>
+    </p:extLst>
+  </p:cSld>
+  <p:clrMapOvr>
+    <a:masterClrMapping/>
+  </p:clrMapOvr>
+</p:notes>
+</file>
+
+<file path=ppt/notesSlides/notesSlide15.xml><?xml version="1.0" encoding="utf-8"?>
+<p:notes xmlns:a="http://schemas.openxmlformats.org/drawingml/2006/main" xmlns:r="http://schemas.openxmlformats.org/officeDocument/2006/relationships" xmlns:p="http://schemas.openxmlformats.org/presentationml/2006/main">
+  <p:cSld>
+    <p:spTree>
+      <p:nvGrpSpPr>
+        <p:cNvPr id="1" name=""/>
+        <p:cNvGrpSpPr/>
+        <p:nvPr/>
+      </p:nvGrpSpPr>
+      <p:grpSpPr>
+        <a:xfrm>
+          <a:off x="0" y="0"/>
+          <a:ext cx="0" cy="0"/>
+          <a:chOff x="0" y="0"/>
+          <a:chExt cx="0" cy="0"/>
+        </a:xfrm>
+      </p:grpSpPr>
+      <p:sp>
+        <p:nvSpPr>
+          <p:cNvPr id="2" name="Slide Image Placeholder 1"/>
+          <p:cNvSpPr>
+            <a:spLocks noGrp="1" noRot="1" noChangeAspect="1"/>
+          </p:cNvSpPr>
+          <p:nvPr>
+            <p:ph type="sldImg"/>
+          </p:nvPr>
+        </p:nvSpPr>
+        <p:spPr/>
+      </p:sp>
+      <p:sp>
+        <p:nvSpPr>
+          <p:cNvPr id="3" name="Notes Placeholder 2"/>
+          <p:cNvSpPr>
+            <a:spLocks noGrp="1"/>
+          </p:cNvSpPr>
+          <p:nvPr>
+            <p:ph type="body" idx="1"/>
+          </p:nvPr>
+        </p:nvSpPr>
+        <p:spPr/>
+        <p:txBody>
+          <a:bodyPr/>
+          <a:lstStyle/>
+          <a:p>
+            <a:r>
+              <a:rPr lang="en-US" dirty="0"/>
+              <a:t>Merci — nous sommes prêts pour vos questions.</a:t>
+            </a:r>
+            <a:endParaRPr lang="en-US" dirty="0"/>
+          </a:p>
+        </p:txBody>
+      </p:sp>
+      <p:sp>
+        <p:nvSpPr>
+          <p:cNvPr id="4" name="Slide Number Placeholder 3"/>
+          <p:cNvSpPr>
+            <a:spLocks noGrp="1"/>
+          </p:cNvSpPr>
+          <p:nvPr>
+            <p:ph type="sldNum" sz="quarter" idx="10"/>
+          </p:nvPr>
+        </p:nvSpPr>
+        <p:spPr/>
+        <p:txBody>
+          <a:bodyPr/>
+          <a:lstStyle/>
+          <a:p>
+            <a:fld id="{F7021451-1387-4CA6-816F-3879F97B5CBC}" type="slidenum">
+              <a:rPr lang="en-US"/>
+              <a:t>15</a:t>
             </a:fld>
             <a:endParaRPr lang="en-US"/>
           </a:p>
@@ -1256,6 +1655,7 @@
               <a:rPr lang="en-US" dirty="0"/>
               <a:t>Trois problèmes concrets : prix fixes, mauvaise gestion des stocks (17,2 Md immobilisés), et catalogue mal exploité.</a:t>
             </a:r>
+            <a:endParaRPr lang="en-US" dirty="0"/>
           </a:p>
         </p:txBody>
       </p:sp>
@@ -1343,6 +1743,7 @@
               <a:rPr lang="en-US" dirty="0"/>
               <a:t>Objectifs SMART : +8% de marge, -20% de ruptures, +15% de conversion, -10% de churn.</a:t>
             </a:r>
+            <a:endParaRPr lang="en-US" dirty="0"/>
           </a:p>
         </p:txBody>
       </p:sp>
@@ -1430,6 +1831,7 @@
               <a:rPr lang="en-US" dirty="0"/>
               <a:t>L'architecture en 6 couches : des sources jusqu'au dashboard, avec Airflow, le MLOps et la gouvernance en transversal.</a:t>
             </a:r>
+            <a:endParaRPr lang="en-US" dirty="0"/>
           </a:p>
         </p:txBody>
       </p:sp>
@@ -1517,6 +1919,7 @@
               <a:rPr lang="en-US" dirty="0"/>
               <a:t>Un jeu 100% synthétique et reproductible : 500 produits, 10 000 clients, 100 000 ventes, 1 M d'événements. Qualité : 21/21.</a:t>
             </a:r>
+            <a:endParaRPr lang="en-US" dirty="0"/>
           </a:p>
         </p:txBody>
       </p:sp>
@@ -1604,6 +2007,7 @@
               <a:rPr lang="en-US" dirty="0"/>
               <a:t>Prophet réduit l'erreur de 34%, et l'ajout des promotions la porte à -43% au total. C'est ce qui alimente la couverture de stock.</a:t>
             </a:r>
+            <a:endParaRPr lang="en-US" dirty="0"/>
           </a:p>
         </p:txBody>
       </p:sp>
@@ -1691,6 +2095,7 @@
               <a:rPr lang="en-US" dirty="0"/>
               <a:t>On estime l'élasticité (~ -2,5) et on calcule le prix optimal : +14% de prix se traduit par +3,8% de marge.</a:t>
             </a:r>
+            <a:endParaRPr lang="en-US" dirty="0"/>
           </a:p>
         </p:txBody>
       </p:sp>
@@ -1778,6 +2183,7 @@
               <a:rPr lang="en-US" dirty="0"/>
               <a:t>On assume un résultat honnête : la popularité est une baseline forte. La reco apporte de la personnalisation, à confirmer par A/B test.</a:t>
             </a:r>
+            <a:endParaRPr lang="en-US" dirty="0"/>
           </a:p>
         </p:txBody>
       </p:sp>
@@ -1865,6 +2271,7 @@
               <a:rPr lang="en-US" dirty="0"/>
               <a:t>Les modèles sont rendus utilisables (API), visibles (dashboard 11 sections) et surveillés (MLOps).</a:t>
             </a:r>
+            <a:endParaRPr lang="en-US" dirty="0"/>
           </a:p>
         </p:txBody>
       </p:sp>
@@ -1937,11 +2344,6 @@
 <file path=ppt/slideMasters/slideMaster1.xml><?xml version="1.0" encoding="utf-8"?>
 <p:sldMaster xmlns:a="http://schemas.openxmlformats.org/drawingml/2006/main" xmlns:r="http://schemas.openxmlformats.org/officeDocument/2006/relationships" xmlns:p="http://schemas.openxmlformats.org/presentationml/2006/main">
   <p:cSld>
-    <p:bg>
-      <p:bgRef idx="1001">
-        <a:schemeClr val="bg1"/>
-      </p:bgRef>
-    </p:bg>
     <p:spTree>
       <p:nvGrpSpPr>
         <p:cNvPr id="1" name=""/>
@@ -2224,7 +2626,6 @@
         <a:solidFill>
           <a:srgbClr val="003B7A"/>
         </a:solidFill>
-        <a:effectLst/>
       </p:bgPr>
     </p:bg>
     <p:spTree>
@@ -2267,7 +2668,7 @@
             <a:prstDash val="solid"/>
           </a:ln>
           <a:effectLst>
-            <a:outerShdw blurRad="76200" dist="25400" dir="5400000" algn="bl" rotWithShape="0">
+            <a:outerShdw sx="100000" sy="100000" kx="0" ky="0" algn="bl" rotWithShape="0" blurRad="76200" dist="25400" dir="5400000">
               <a:srgbClr val="9AA7B4">
                 <a:alpha val="35000"/>
               </a:srgbClr>
@@ -2277,14 +2678,14 @@
       </p:sp>
       <p:pic>
         <p:nvPicPr>
-          <p:cNvPr id="3" name="Image 0" descr="preencoded.png"/>
+          <p:cNvPr id="3" name="Image 0" descr="preencoded.png">    </p:cNvPr>
           <p:cNvPicPr>
             <a:picLocks noChangeAspect="1"/>
           </p:cNvPicPr>
           <p:nvPr/>
         </p:nvPicPr>
         <p:blipFill>
-          <a:blip r:embed="rId3"/>
+          <a:blip r:embed="rId1"/>
           <a:stretch>
             <a:fillRect/>
           </a:stretch>
@@ -2320,7 +2721,7 @@
           <a:bodyPr wrap="square" rtlCol="0" anchor="ctr"/>
           <a:lstStyle/>
           <a:p>
-            <a:pPr marL="0" indent="0" algn="ctr">
+            <a:pPr algn="ctr" indent="0" marL="0">
               <a:buNone/>
             </a:pPr>
             <a:r>
@@ -2359,7 +2760,7 @@
           <a:bodyPr wrap="square" rtlCol="0" anchor="ctr"/>
           <a:lstStyle/>
           <a:p>
-            <a:pPr marL="0" indent="0" algn="ctr">
+            <a:pPr algn="ctr" indent="0" marL="0">
               <a:buNone/>
             </a:pPr>
             <a:r>
@@ -2398,7 +2799,7 @@
           <a:bodyPr wrap="square" rtlCol="0" anchor="ctr"/>
           <a:lstStyle/>
           <a:p>
-            <a:pPr marL="0" indent="0" algn="ctr">
+            <a:pPr algn="ctr" indent="0" marL="0">
               <a:spcAft>
                 <a:spcPts val="800"/>
               </a:spcAft>
@@ -2418,7 +2819,7 @@
             <a:endParaRPr lang="en-US" sz="1400" dirty="0"/>
           </a:p>
           <a:p>
-            <a:pPr marL="0" indent="0" algn="ctr">
+            <a:pPr algn="ctr" indent="0" marL="0">
               <a:spcAft>
                 <a:spcPts val="800"/>
               </a:spcAft>
@@ -2438,7 +2839,7 @@
             <a:endParaRPr lang="en-US" sz="1400" dirty="0"/>
           </a:p>
           <a:p>
-            <a:pPr marL="0" indent="0" algn="ctr">
+            <a:pPr algn="ctr" indent="0" marL="0">
               <a:spcAft>
                 <a:spcPts val="800"/>
               </a:spcAft>
@@ -2475,7 +2876,6 @@
         <a:solidFill>
           <a:srgbClr val="003B7A"/>
         </a:solidFill>
-        <a:effectLst/>
       </p:bgPr>
     </p:bg>
     <p:spTree>
@@ -2513,7 +2913,7 @@
           <a:bodyPr wrap="square" rtlCol="0" anchor="ctr"/>
           <a:lstStyle/>
           <a:p>
-            <a:pPr marL="0" indent="0">
+            <a:pPr indent="0" marL="0">
               <a:buNone/>
             </a:pPr>
             <a:r>
@@ -2552,7 +2952,7 @@
           <a:bodyPr wrap="square" rtlCol="0" anchor="ctr"/>
           <a:lstStyle/>
           <a:p>
-            <a:pPr marL="0" indent="0">
+            <a:pPr indent="0" marL="0">
               <a:buNone/>
             </a:pPr>
             <a:r>
@@ -2596,7 +2996,7 @@
             <a:prstDash val="solid"/>
           </a:ln>
           <a:effectLst>
-            <a:outerShdw blurRad="76200" dist="25400" dir="5400000" algn="bl" rotWithShape="0">
+            <a:outerShdw sx="100000" sy="100000" kx="0" ky="0" algn="bl" rotWithShape="0" blurRad="76200" dist="25400" dir="5400000">
               <a:srgbClr val="9AA7B4">
                 <a:alpha val="35000"/>
               </a:srgbClr>
@@ -2625,7 +3025,7 @@
           <a:bodyPr wrap="square" lIns="0" tIns="0" rIns="0" bIns="0" rtlCol="0" anchor="ctr"/>
           <a:lstStyle/>
           <a:p>
-            <a:pPr marL="0" indent="0" algn="ctr">
+            <a:pPr algn="ctr" indent="0" marL="0">
               <a:buNone/>
             </a:pPr>
             <a:r>
@@ -2664,7 +3064,7 @@
           <a:bodyPr wrap="square" lIns="0" tIns="0" rIns="0" bIns="0" rtlCol="0" anchor="ctr"/>
           <a:lstStyle/>
           <a:p>
-            <a:pPr marL="0" indent="0" algn="ctr">
+            <a:pPr algn="ctr" indent="0" marL="0">
               <a:buNone/>
             </a:pPr>
             <a:r>
@@ -2708,7 +3108,7 @@
             <a:prstDash val="solid"/>
           </a:ln>
           <a:effectLst>
-            <a:outerShdw blurRad="76200" dist="25400" dir="5400000" algn="bl" rotWithShape="0">
+            <a:outerShdw sx="100000" sy="100000" kx="0" ky="0" algn="bl" rotWithShape="0" blurRad="76200" dist="25400" dir="5400000">
               <a:srgbClr val="9AA7B4">
                 <a:alpha val="35000"/>
               </a:srgbClr>
@@ -2737,7 +3137,7 @@
           <a:bodyPr wrap="square" lIns="0" tIns="0" rIns="0" bIns="0" rtlCol="0" anchor="ctr"/>
           <a:lstStyle/>
           <a:p>
-            <a:pPr marL="0" indent="0" algn="ctr">
+            <a:pPr algn="ctr" indent="0" marL="0">
               <a:buNone/>
             </a:pPr>
             <a:r>
@@ -2776,7 +3176,7 @@
           <a:bodyPr wrap="square" lIns="0" tIns="0" rIns="0" bIns="0" rtlCol="0" anchor="ctr"/>
           <a:lstStyle/>
           <a:p>
-            <a:pPr marL="0" indent="0" algn="ctr">
+            <a:pPr algn="ctr" indent="0" marL="0">
               <a:buNone/>
             </a:pPr>
             <a:r>
@@ -2820,7 +3220,7 @@
             <a:prstDash val="solid"/>
           </a:ln>
           <a:effectLst>
-            <a:outerShdw blurRad="76200" dist="25400" dir="5400000" algn="bl" rotWithShape="0">
+            <a:outerShdw sx="100000" sy="100000" kx="0" ky="0" algn="bl" rotWithShape="0" blurRad="76200" dist="25400" dir="5400000">
               <a:srgbClr val="9AA7B4">
                 <a:alpha val="35000"/>
               </a:srgbClr>
@@ -2849,7 +3249,7 @@
           <a:bodyPr wrap="square" lIns="0" tIns="0" rIns="0" bIns="0" rtlCol="0" anchor="ctr"/>
           <a:lstStyle/>
           <a:p>
-            <a:pPr marL="0" indent="0" algn="ctr">
+            <a:pPr algn="ctr" indent="0" marL="0">
               <a:buNone/>
             </a:pPr>
             <a:r>
@@ -2888,7 +3288,7 @@
           <a:bodyPr wrap="square" lIns="0" tIns="0" rIns="0" bIns="0" rtlCol="0" anchor="ctr"/>
           <a:lstStyle/>
           <a:p>
-            <a:pPr marL="0" indent="0" algn="ctr">
+            <a:pPr algn="ctr" indent="0" marL="0">
               <a:buNone/>
             </a:pPr>
             <a:r>
@@ -2927,7 +3327,7 @@
           <a:bodyPr wrap="square" rtlCol="0" anchor="ctr"/>
           <a:lstStyle/>
           <a:p>
-            <a:pPr marL="0" indent="0" algn="ctr">
+            <a:pPr algn="ctr" indent="0" marL="0">
               <a:buNone/>
             </a:pPr>
             <a:r>
@@ -2961,7 +3361,6 @@
         <a:solidFill>
           <a:srgbClr val="FFFFFF"/>
         </a:solidFill>
-        <a:effectLst/>
       </p:bgPr>
     </p:bg>
     <p:spTree>
@@ -2999,7 +3398,7 @@
           <a:bodyPr wrap="square" rtlCol="0" anchor="ctr"/>
           <a:lstStyle/>
           <a:p>
-            <a:pPr marL="0" indent="0">
+            <a:pPr indent="0" marL="0">
               <a:buNone/>
             </a:pPr>
             <a:r>
@@ -3011,7 +3410,7 @@
                 <a:ea typeface="Calibri" pitchFamily="34" charset="-122"/>
                 <a:cs typeface="Calibri" pitchFamily="34" charset="-120"/>
               </a:rPr>
-              <a:t>Démonstration</a:t>
+              <a:t>Accès en ligne — testez le projet</a:t>
             </a:r>
             <a:endParaRPr lang="en-US" sz="3200" dirty="0"/>
           </a:p>
@@ -3025,8 +3424,8 @@
         </p:nvSpPr>
         <p:spPr>
           <a:xfrm>
-            <a:off x="548640" y="1188720"/>
-            <a:ext cx="10972800" cy="457200"/>
+            <a:off x="548640" y="1143000"/>
+            <a:ext cx="11064240" cy="457200"/>
           </a:xfrm>
           <a:prstGeom prst="rect">
             <a:avLst/>
@@ -3038,34 +3437,68 @@
           <a:bodyPr wrap="square" rtlCol="0" anchor="ctr"/>
           <a:lstStyle/>
           <a:p>
-            <a:pPr marL="0" indent="0">
-              <a:buNone/>
-            </a:pPr>
-            <a:r>
-              <a:rPr lang="en-US" sz="1700" dirty="0">
-                <a:solidFill>
-                  <a:srgbClr val="1B2A3A"/>
-                </a:solidFill>
-                <a:latin typeface="Calibri" pitchFamily="34" charset="0"/>
-                <a:ea typeface="Calibri" pitchFamily="34" charset="-122"/>
-                <a:cs typeface="Calibri" pitchFamily="34" charset="-120"/>
-              </a:rPr>
-              <a:t>Parcours live dans le dashboard (API + Dash) :</a:t>
-            </a:r>
-            <a:endParaRPr lang="en-US" sz="1700" dirty="0"/>
-          </a:p>
-        </p:txBody>
-      </p:sp>
-      <p:sp>
-        <p:nvSpPr>
-          <p:cNvPr id="4" name="Text 2"/>
-          <p:cNvSpPr/>
-          <p:nvPr/>
-        </p:nvSpPr>
-        <p:spPr>
-          <a:xfrm>
-            <a:off x="822960" y="1920240"/>
-            <a:ext cx="10515600" cy="3200400"/>
+            <a:pPr indent="0" marL="0">
+              <a:buNone/>
+            </a:pPr>
+            <a:r>
+              <a:rPr lang="en-US" sz="1600" dirty="0">
+                <a:solidFill>
+                  <a:srgbClr val="6B7887"/>
+                </a:solidFill>
+                <a:latin typeface="Calibri" pitchFamily="34" charset="0"/>
+                <a:ea typeface="Calibri" pitchFamily="34" charset="-122"/>
+                <a:cs typeface="Calibri" pitchFamily="34" charset="-120"/>
+              </a:rPr>
+              <a:t>Déployé sur Render : dashboard et API accessibles directement, sans rien installer.</a:t>
+            </a:r>
+            <a:endParaRPr lang="en-US" sz="1600" dirty="0"/>
+          </a:p>
+        </p:txBody>
+      </p:sp>
+      <p:sp>
+        <p:nvSpPr>
+          <p:cNvPr id="4" name="Shape 2"/>
+          <p:cNvSpPr/>
+          <p:nvPr/>
+        </p:nvSpPr>
+        <p:spPr>
+          <a:xfrm>
+            <a:off x="548640" y="1828800"/>
+            <a:ext cx="5577840" cy="1371600"/>
+          </a:xfrm>
+          <a:prstGeom prst="roundRect">
+            <a:avLst>
+              <a:gd name="adj" fmla="val 6000"/>
+            </a:avLst>
+          </a:prstGeom>
+          <a:solidFill>
+            <a:srgbClr val="EAF1F9"/>
+          </a:solidFill>
+          <a:ln w="12700">
+            <a:solidFill>
+              <a:srgbClr val="EAF1F9"/>
+            </a:solidFill>
+            <a:prstDash val="solid"/>
+          </a:ln>
+          <a:effectLst>
+            <a:outerShdw sx="100000" sy="100000" kx="0" ky="0" algn="bl" rotWithShape="0" blurRad="76200" dist="25400" dir="5400000">
+              <a:srgbClr val="9AA7B4">
+                <a:alpha val="35000"/>
+              </a:srgbClr>
+            </a:outerShdw>
+          </a:effectLst>
+        </p:spPr>
+      </p:sp>
+      <p:sp>
+        <p:nvSpPr>
+          <p:cNvPr id="5" name="Text 3"/>
+          <p:cNvSpPr/>
+          <p:nvPr/>
+        </p:nvSpPr>
+        <p:spPr>
+          <a:xfrm>
+            <a:off x="777240" y="2103120"/>
+            <a:ext cx="5120640" cy="914400"/>
           </a:xfrm>
           <a:prstGeom prst="rect">
             <a:avLst/>
@@ -3077,105 +3510,222 @@
           <a:bodyPr wrap="square" rtlCol="0" anchor="t"/>
           <a:lstStyle/>
           <a:p>
-            <a:pPr marL="342900" indent="-342900">
-              <a:spcAft>
-                <a:spcPts val="1200"/>
-              </a:spcAft>
-              <a:buSzPct val="100000"/>
-              <a:buChar char="•"/>
-            </a:pPr>
-            <a:r>
-              <a:rPr lang="en-US" sz="1700" dirty="0">
-                <a:solidFill>
-                  <a:srgbClr val="1B2A3A"/>
-                </a:solidFill>
-                <a:latin typeface="Calibri" pitchFamily="34" charset="0"/>
-                <a:ea typeface="Calibri" pitchFamily="34" charset="-122"/>
-                <a:cs typeface="Calibri" pitchFamily="34" charset="-120"/>
-              </a:rPr>
-              <a:t>Les KPIs de pilotage (CA, marge, conversion, rotation de stock, CLTV)</a:t>
+            <a:pPr indent="0" marL="0">
+              <a:buNone/>
+            </a:pPr>
+            <a:r>
+              <a:rPr lang="en-US" sz="1700" b="1" dirty="0">
+                <a:solidFill>
+                  <a:srgbClr val="003B7A"/>
+                </a:solidFill>
+                <a:latin typeface="Calibri" pitchFamily="34" charset="0"/>
+                <a:ea typeface="Calibri" pitchFamily="34" charset="-122"/>
+                <a:cs typeface="Calibri" pitchFamily="34" charset="-120"/>
+              </a:rPr>
+              <a:t>Dashboard décisionnel</a:t>
             </a:r>
             <a:endParaRPr lang="en-US" sz="1700" dirty="0"/>
           </a:p>
           <a:p>
-            <a:pPr marL="342900" indent="-342900">
-              <a:spcAft>
-                <a:spcPts val="1200"/>
-              </a:spcAft>
-              <a:buSzPct val="100000"/>
-              <a:buChar char="•"/>
-            </a:pPr>
-            <a:r>
-              <a:rPr lang="en-US" sz="1700" dirty="0">
-                <a:solidFill>
-                  <a:srgbClr val="1B2A3A"/>
-                </a:solidFill>
-                <a:latin typeface="Calibri" pitchFamily="34" charset="0"/>
-                <a:ea typeface="Calibri" pitchFamily="34" charset="-122"/>
-                <a:cs typeface="Calibri" pitchFamily="34" charset="-120"/>
-              </a:rPr>
-              <a:t>Le simulateur de prix « et si… » : faire varier un prix, voir la marge évoluer en direct</a:t>
+            <a:pPr indent="0" marL="0">
+              <a:buNone/>
+            </a:pPr>
+            <a:r>
+              <a:rPr lang="en-US" sz="1300" u="sng" dirty="0">
+                <a:solidFill>
+                  <a:srgbClr val="0A4C93"/>
+                </a:solidFill>
+                <a:latin typeface="Calibri" pitchFamily="34" charset="0"/>
+                <a:ea typeface="Calibri" pitchFamily="34" charset="-122"/>
+                <a:cs typeface="Calibri" pitchFamily="34" charset="-120"/>
+                <a:hlinkClick r:id="rId1" invalidUrl="" action="" tgtFrame="" tooltip="" history="1" highlightClick="0" endSnd="0">
+                  <a:extLst>
+                    <a:ext uri="{A12FA001-AC4F-418D-AE19-62706E023703}">
+                      <ahyp:hlinkClr xmlns:ahyp="http://schemas.microsoft.com/office/drawing/2018/hyperlinkcolor" val="tx"/>
+                    </a:ext>
+                  </a:extLst>
+                </a:hlinkClick>
+              </a:rPr>
+              <a:t>https://teranga-dashboard.onrender.com</a:t>
             </a:r>
             <a:endParaRPr lang="en-US" sz="1700" dirty="0"/>
           </a:p>
-          <a:p>
-            <a:pPr marL="342900" indent="-342900">
-              <a:spcAft>
-                <a:spcPts val="1200"/>
-              </a:spcAft>
-              <a:buSzPct val="100000"/>
-              <a:buChar char="•"/>
-            </a:pPr>
-            <a:r>
-              <a:rPr lang="en-US" sz="1700" dirty="0">
-                <a:solidFill>
-                  <a:srgbClr val="1B2A3A"/>
-                </a:solidFill>
-                <a:latin typeface="Calibri" pitchFamily="34" charset="0"/>
-                <a:ea typeface="Calibri" pitchFamily="34" charset="-122"/>
-                <a:cs typeface="Calibri" pitchFamily="34" charset="-120"/>
-              </a:rPr>
-              <a:t>La couverture de stock : catégories saines vs surstock</a:t>
-            </a:r>
-            <a:endParaRPr lang="en-US" sz="1700" dirty="0"/>
-          </a:p>
-          <a:p>
-            <a:pPr marL="342900" indent="-342900">
-              <a:spcAft>
-                <a:spcPts val="1200"/>
-              </a:spcAft>
-              <a:buSzPct val="100000"/>
-              <a:buChar char="•"/>
-            </a:pPr>
-            <a:r>
-              <a:rPr lang="en-US" sz="1700" dirty="0">
-                <a:solidFill>
-                  <a:srgbClr val="1B2A3A"/>
-                </a:solidFill>
-                <a:latin typeface="Calibri" pitchFamily="34" charset="0"/>
-                <a:ea typeface="Calibri" pitchFamily="34" charset="-122"/>
-                <a:cs typeface="Calibri" pitchFamily="34" charset="-120"/>
-              </a:rPr>
-              <a:t>La recommandation en direct : saisir un client → appel API → recommandations</a:t>
-            </a:r>
-            <a:endParaRPr lang="en-US" sz="1700" dirty="0"/>
-          </a:p>
-        </p:txBody>
-      </p:sp>
-      <p:sp>
-        <p:nvSpPr>
-          <p:cNvPr id="5" name="Shape 3"/>
-          <p:cNvSpPr/>
-          <p:nvPr/>
-        </p:nvSpPr>
-        <p:spPr>
-          <a:xfrm>
-            <a:off x="548640" y="5394960"/>
-            <a:ext cx="11091672" cy="914400"/>
+        </p:txBody>
+      </p:sp>
+      <p:sp>
+        <p:nvSpPr>
+          <p:cNvPr id="6" name="Shape 4"/>
+          <p:cNvSpPr/>
+          <p:nvPr/>
+        </p:nvSpPr>
+        <p:spPr>
+          <a:xfrm>
+            <a:off x="548640" y="3429000"/>
+            <a:ext cx="5577840" cy="1371600"/>
           </a:xfrm>
           <a:prstGeom prst="roundRect">
             <a:avLst>
-              <a:gd name="adj" fmla="val 9000"/>
+              <a:gd name="adj" fmla="val 6000"/>
+            </a:avLst>
+          </a:prstGeom>
+          <a:solidFill>
+            <a:srgbClr val="EAF1F9"/>
+          </a:solidFill>
+          <a:ln w="12700">
+            <a:solidFill>
+              <a:srgbClr val="EAF1F9"/>
+            </a:solidFill>
+            <a:prstDash val="solid"/>
+          </a:ln>
+          <a:effectLst>
+            <a:outerShdw sx="100000" sy="100000" kx="0" ky="0" algn="bl" rotWithShape="0" blurRad="76200" dist="25400" dir="5400000">
+              <a:srgbClr val="9AA7B4">
+                <a:alpha val="35000"/>
+              </a:srgbClr>
+            </a:outerShdw>
+          </a:effectLst>
+        </p:spPr>
+      </p:sp>
+      <p:sp>
+        <p:nvSpPr>
+          <p:cNvPr id="7" name="Text 5"/>
+          <p:cNvSpPr/>
+          <p:nvPr/>
+        </p:nvSpPr>
+        <p:spPr>
+          <a:xfrm>
+            <a:off x="777240" y="3703320"/>
+            <a:ext cx="5120640" cy="914400"/>
+          </a:xfrm>
+          <a:prstGeom prst="rect">
+            <a:avLst/>
+          </a:prstGeom>
+          <a:noFill/>
+          <a:ln/>
+        </p:spPr>
+        <p:txBody>
+          <a:bodyPr wrap="square" rtlCol="0" anchor="t"/>
+          <a:lstStyle/>
+          <a:p>
+            <a:pPr indent="0" marL="0">
+              <a:buNone/>
+            </a:pPr>
+            <a:r>
+              <a:rPr lang="en-US" sz="1700" b="1" dirty="0">
+                <a:solidFill>
+                  <a:srgbClr val="003B7A"/>
+                </a:solidFill>
+                <a:latin typeface="Calibri" pitchFamily="34" charset="0"/>
+                <a:ea typeface="Calibri" pitchFamily="34" charset="-122"/>
+                <a:cs typeface="Calibri" pitchFamily="34" charset="-120"/>
+              </a:rPr>
+              <a:t>API — documentation Swagger</a:t>
+            </a:r>
+            <a:endParaRPr lang="en-US" sz="1700" dirty="0"/>
+          </a:p>
+          <a:p>
+            <a:pPr indent="0" marL="0">
+              <a:buNone/>
+            </a:pPr>
+            <a:r>
+              <a:rPr lang="en-US" sz="1300" u="sng" dirty="0">
+                <a:solidFill>
+                  <a:srgbClr val="0A4C93"/>
+                </a:solidFill>
+                <a:latin typeface="Calibri" pitchFamily="34" charset="0"/>
+                <a:ea typeface="Calibri" pitchFamily="34" charset="-122"/>
+                <a:cs typeface="Calibri" pitchFamily="34" charset="-120"/>
+                <a:hlinkClick r:id="rId2" invalidUrl="" action="" tgtFrame="" tooltip="" history="1" highlightClick="0" endSnd="0">
+                  <a:extLst>
+                    <a:ext uri="{A12FA001-AC4F-418D-AE19-62706E023703}">
+                      <ahyp:hlinkClr xmlns:ahyp="http://schemas.microsoft.com/office/drawing/2018/hyperlinkcolor" val="tx"/>
+                    </a:ext>
+                  </a:extLst>
+                </a:hlinkClick>
+              </a:rPr>
+              <a:t>https://teranga-api-8qnb.onrender.com/docs</a:t>
+            </a:r>
+            <a:endParaRPr lang="en-US" sz="1700" dirty="0"/>
+          </a:p>
+        </p:txBody>
+      </p:sp>
+      <p:pic>
+        <p:nvPicPr>
+          <p:cNvPr id="8" name="Image 0" descr="preencoded.png">    </p:cNvPr>
+          <p:cNvPicPr>
+            <a:picLocks noChangeAspect="1"/>
+          </p:cNvPicPr>
+          <p:nvPr/>
+        </p:nvPicPr>
+        <p:blipFill>
+          <a:blip r:embed="rId3"/>
+          <a:stretch>
+            <a:fillRect/>
+          </a:stretch>
+        </p:blipFill>
+        <p:spPr>
+          <a:xfrm>
+            <a:off x="6400800" y="1828800"/>
+            <a:ext cx="5212080" cy="2249424"/>
+          </a:xfrm>
+          <a:prstGeom prst="rect">
+            <a:avLst/>
+          </a:prstGeom>
+        </p:spPr>
+      </p:pic>
+      <p:sp>
+        <p:nvSpPr>
+          <p:cNvPr id="9" name="Text 6"/>
+          <p:cNvSpPr/>
+          <p:nvPr/>
+        </p:nvSpPr>
+        <p:spPr>
+          <a:xfrm>
+            <a:off x="6400800" y="4114800"/>
+            <a:ext cx="5212080" cy="365760"/>
+          </a:xfrm>
+          <a:prstGeom prst="rect">
+            <a:avLst/>
+          </a:prstGeom>
+          <a:noFill/>
+          <a:ln/>
+        </p:spPr>
+        <p:txBody>
+          <a:bodyPr wrap="square" rtlCol="0" anchor="ctr"/>
+          <a:lstStyle/>
+          <a:p>
+            <a:pPr algn="ctr" indent="0" marL="0">
+              <a:buNone/>
+            </a:pPr>
+            <a:r>
+              <a:rPr lang="en-US" sz="1200" i="1" dirty="0">
+                <a:solidFill>
+                  <a:srgbClr val="6B7887"/>
+                </a:solidFill>
+                <a:latin typeface="Calibri" pitchFamily="34" charset="0"/>
+                <a:ea typeface="Calibri" pitchFamily="34" charset="-122"/>
+                <a:cs typeface="Calibri" pitchFamily="34" charset="-120"/>
+              </a:rPr>
+              <a:t>L'API en ligne (Swagger)</a:t>
+            </a:r>
+            <a:endParaRPr lang="en-US" sz="1200" dirty="0"/>
+          </a:p>
+        </p:txBody>
+      </p:sp>
+      <p:sp>
+        <p:nvSpPr>
+          <p:cNvPr id="10" name="Shape 7"/>
+          <p:cNvSpPr/>
+          <p:nvPr/>
+        </p:nvSpPr>
+        <p:spPr>
+          <a:xfrm>
+            <a:off x="548640" y="5394960"/>
+            <a:ext cx="11091672" cy="960120"/>
+          </a:xfrm>
+          <a:prstGeom prst="roundRect">
+            <a:avLst>
+              <a:gd name="adj" fmla="val 8571"/>
             </a:avLst>
           </a:prstGeom>
           <a:solidFill>
@@ -3188,7 +3738,7 @@
             <a:prstDash val="solid"/>
           </a:ln>
           <a:effectLst>
-            <a:outerShdw blurRad="76200" dist="25400" dir="5400000" algn="bl" rotWithShape="0">
+            <a:outerShdw sx="100000" sy="100000" kx="0" ky="0" algn="bl" rotWithShape="0" blurRad="76200" dist="25400" dir="5400000">
               <a:srgbClr val="9AA7B4">
                 <a:alpha val="35000"/>
               </a:srgbClr>
@@ -3198,14 +3748,14 @@
       </p:sp>
       <p:sp>
         <p:nvSpPr>
-          <p:cNvPr id="6" name="Text 4"/>
+          <p:cNvPr id="11" name="Text 8"/>
           <p:cNvSpPr/>
           <p:nvPr/>
         </p:nvSpPr>
         <p:spPr>
           <a:xfrm>
             <a:off x="822960" y="5532120"/>
-            <a:ext cx="10515600" cy="640080"/>
+            <a:ext cx="10515600" cy="685800"/>
           </a:xfrm>
           <a:prstGeom prst="rect">
             <a:avLst/>
@@ -3217,11 +3767,11 @@
           <a:bodyPr wrap="square" rtlCol="0" anchor="ctr"/>
           <a:lstStyle/>
           <a:p>
-            <a:pPr marL="0" indent="0">
-              <a:buNone/>
-            </a:pPr>
-            <a:r>
-              <a:rPr lang="en-US" sz="1500" i="1" dirty="0">
+            <a:pPr indent="0" marL="0">
+              <a:buNone/>
+            </a:pPr>
+            <a:r>
+              <a:rPr lang="en-US" sz="1400" i="1" dirty="0">
                 <a:solidFill>
                   <a:srgbClr val="003B7A"/>
                 </a:solidFill>
@@ -3229,9 +3779,9 @@
                 <a:ea typeface="Calibri" pitchFamily="34" charset="-122"/>
                 <a:cs typeface="Calibri" pitchFamily="34" charset="-120"/>
               </a:rPr>
-              <a:t>⚠  Prévoir 2 terminaux : API (uvicorn, port 8000) + dashboard (python app.py, port 8050).</a:t>
-            </a:r>
-            <a:endParaRPr lang="en-US" sz="1500" dirty="0"/>
+              <a:t>1ère ouverture ~30-60 s (réveil du service gratuit).  ·  Pipeline (Airflow) et MLflow : exécutables en local → captures ci-après.</a:t>
+            </a:r>
+            <a:endParaRPr lang="en-US" sz="1400" dirty="0"/>
           </a:p>
         </p:txBody>
       </p:sp>
@@ -3251,7 +3801,6 @@
         <a:solidFill>
           <a:srgbClr val="FFFFFF"/>
         </a:solidFill>
-        <a:effectLst/>
       </p:bgPr>
     </p:bg>
     <p:spTree>
@@ -3289,7 +3838,7 @@
           <a:bodyPr wrap="square" rtlCol="0" anchor="ctr"/>
           <a:lstStyle/>
           <a:p>
-            <a:pPr marL="0" indent="0">
+            <a:pPr indent="0" marL="0">
               <a:buNone/>
             </a:pPr>
             <a:r>
@@ -3301,22 +3850,46 @@
                 <a:ea typeface="Calibri" pitchFamily="34" charset="-122"/>
                 <a:cs typeface="Calibri" pitchFamily="34" charset="-120"/>
               </a:rPr>
-              <a:t>Conclusion &amp; recommandations</a:t>
+              <a:t>Pipeline de données — Airflow</a:t>
             </a:r>
             <a:endParaRPr lang="en-US" sz="3200" dirty="0"/>
           </a:p>
         </p:txBody>
       </p:sp>
-      <p:sp>
-        <p:nvSpPr>
-          <p:cNvPr id="3" name="Text 1"/>
-          <p:cNvSpPr/>
-          <p:nvPr/>
-        </p:nvSpPr>
-        <p:spPr>
-          <a:xfrm>
-            <a:off x="822960" y="1737360"/>
-            <a:ext cx="10515600" cy="4114800"/>
+      <p:pic>
+        <p:nvPicPr>
+          <p:cNvPr id="3" name="Image 0" descr="preencoded.png">    </p:cNvPr>
+          <p:cNvPicPr>
+            <a:picLocks noChangeAspect="1"/>
+          </p:cNvPicPr>
+          <p:nvPr/>
+        </p:nvPicPr>
+        <p:blipFill>
+          <a:blip r:embed="rId1"/>
+          <a:stretch>
+            <a:fillRect/>
+          </a:stretch>
+        </p:blipFill>
+        <p:spPr>
+          <a:xfrm>
+            <a:off x="1060704" y="1280160"/>
+            <a:ext cx="10058400" cy="4370832"/>
+          </a:xfrm>
+          <a:prstGeom prst="rect">
+            <a:avLst/>
+          </a:prstGeom>
+        </p:spPr>
+      </p:pic>
+      <p:sp>
+        <p:nvSpPr>
+          <p:cNvPr id="4" name="Text 1"/>
+          <p:cNvSpPr/>
+          <p:nvPr/>
+        </p:nvSpPr>
+        <p:spPr>
+          <a:xfrm>
+            <a:off x="822960" y="5806440"/>
+            <a:ext cx="10515600" cy="640080"/>
           </a:xfrm>
           <a:prstGeom prst="rect">
             <a:avLst/>
@@ -3325,18 +3898,14 @@
           <a:ln/>
         </p:spPr>
         <p:txBody>
-          <a:bodyPr wrap="square" rtlCol="0" anchor="t"/>
-          <a:lstStyle/>
-          <a:p>
-            <a:pPr marL="342900" indent="-342900">
-              <a:spcAft>
-                <a:spcPts val="1400"/>
-              </a:spcAft>
-              <a:buSzPct val="100000"/>
-              <a:buChar char="•"/>
-            </a:pPr>
-            <a:r>
-              <a:rPr lang="en-US" sz="1800" dirty="0">
+          <a:bodyPr wrap="square" rtlCol="0" anchor="ctr"/>
+          <a:lstStyle/>
+          <a:p>
+            <a:pPr algn="ctr" indent="0" marL="0">
+              <a:buNone/>
+            </a:pPr>
+            <a:r>
+              <a:rPr lang="en-US" sz="1400" i="1" dirty="0">
                 <a:solidFill>
                   <a:srgbClr val="1B2A3A"/>
                 </a:solidFill>
@@ -3344,69 +3913,9 @@
                 <a:ea typeface="Calibri" pitchFamily="34" charset="-122"/>
                 <a:cs typeface="Calibri" pitchFamily="34" charset="-120"/>
               </a:rPr>
-              <a:t>Une chaîne fonctionnelle de bout en bout — des données brutes à des décisions chiffrées.</a:t>
-            </a:r>
-            <a:endParaRPr lang="en-US" sz="1800" dirty="0"/>
-          </a:p>
-          <a:p>
-            <a:pPr marL="342900" indent="-342900">
-              <a:spcAft>
-                <a:spcPts val="1400"/>
-              </a:spcAft>
-              <a:buSzPct val="100000"/>
-              <a:buChar char="•"/>
-            </a:pPr>
-            <a:r>
-              <a:rPr lang="en-US" sz="1800" dirty="0">
-                <a:solidFill>
-                  <a:srgbClr val="1B2A3A"/>
-                </a:solidFill>
-                <a:latin typeface="Calibri" pitchFamily="34" charset="0"/>
-                <a:ea typeface="Calibri" pitchFamily="34" charset="-122"/>
-                <a:cs typeface="Calibri" pitchFamily="34" charset="-120"/>
-              </a:rPr>
-              <a:t>Trois modèles évalués face à des baselines + une valeur business démontrée.</a:t>
-            </a:r>
-            <a:endParaRPr lang="en-US" sz="1800" dirty="0"/>
-          </a:p>
-          <a:p>
-            <a:pPr marL="342900" indent="-342900">
-              <a:spcAft>
-                <a:spcPts val="1400"/>
-              </a:spcAft>
-              <a:buSzPct val="100000"/>
-              <a:buChar char="•"/>
-            </a:pPr>
-            <a:r>
-              <a:rPr lang="en-US" sz="1800" b="1" dirty="0">
-                <a:solidFill>
-                  <a:srgbClr val="1E8449"/>
-                </a:solidFill>
-                <a:latin typeface="Calibri" pitchFamily="34" charset="0"/>
-                <a:ea typeface="Calibri" pitchFamily="34" charset="-122"/>
-                <a:cs typeface="Calibri" pitchFamily="34" charset="-120"/>
-              </a:rPr>
-              <a:t>Recommandation : GO, en déploiement progressif (pricing → prévision → reco après A/B test), avec monitoring continu.</a:t>
-            </a:r>
-            <a:endParaRPr lang="en-US" sz="1800" dirty="0"/>
-          </a:p>
-          <a:p>
-            <a:pPr marL="342900" indent="-342900">
-              <a:buSzPct val="100000"/>
-              <a:buChar char="•"/>
-            </a:pPr>
-            <a:r>
-              <a:rPr lang="en-US" sz="1800" dirty="0">
-                <a:solidFill>
-                  <a:srgbClr val="1B2A3A"/>
-                </a:solidFill>
-                <a:latin typeface="Calibri" pitchFamily="34" charset="0"/>
-                <a:ea typeface="Calibri" pitchFamily="34" charset="-122"/>
-                <a:cs typeface="Calibri" pitchFamily="34" charset="-120"/>
-              </a:rPr>
-              <a:t>Perspectives : A/B testing, pricing temps réel, modélisation CLTV / churn.</a:t>
-            </a:r>
-            <a:endParaRPr lang="en-US" sz="1800" dirty="0"/>
+              <a:t>DAG « pipeline_teranga » : génération → ingestion Parquet → warehouse DuckDB → contrôle qualité — toutes les étapes en succès.</a:t>
+            </a:r>
+            <a:endParaRPr lang="en-US" sz="1400" dirty="0"/>
           </a:p>
         </p:txBody>
       </p:sp>
@@ -3424,9 +3933,8 @@
     <p:bg>
       <p:bgPr>
         <a:solidFill>
-          <a:srgbClr val="003B7A"/>
+          <a:srgbClr val="FFFFFF"/>
         </a:solidFill>
-        <a:effectLst/>
       </p:bgPr>
     </p:bg>
     <p:spTree>
@@ -3445,6 +3953,314 @@
       </p:grpSpPr>
       <p:sp>
         <p:nvSpPr>
+          <p:cNvPr id="2" name="Text 0"/>
+          <p:cNvSpPr/>
+          <p:nvPr/>
+        </p:nvSpPr>
+        <p:spPr>
+          <a:xfrm>
+            <a:off x="548640" y="320040"/>
+            <a:ext cx="11064240" cy="822960"/>
+          </a:xfrm>
+          <a:prstGeom prst="rect">
+            <a:avLst/>
+          </a:prstGeom>
+          <a:noFill/>
+          <a:ln/>
+        </p:spPr>
+        <p:txBody>
+          <a:bodyPr wrap="square" rtlCol="0" anchor="ctr"/>
+          <a:lstStyle/>
+          <a:p>
+            <a:pPr indent="0" marL="0">
+              <a:buNone/>
+            </a:pPr>
+            <a:r>
+              <a:rPr lang="en-US" sz="3200" b="1" dirty="0">
+                <a:solidFill>
+                  <a:srgbClr val="003B7A"/>
+                </a:solidFill>
+                <a:latin typeface="Calibri" pitchFamily="34" charset="0"/>
+                <a:ea typeface="Calibri" pitchFamily="34" charset="-122"/>
+                <a:cs typeface="Calibri" pitchFamily="34" charset="-120"/>
+              </a:rPr>
+              <a:t>MLOps — suivi des modèles (MLflow)</a:t>
+            </a:r>
+            <a:endParaRPr lang="en-US" sz="3200" dirty="0"/>
+          </a:p>
+        </p:txBody>
+      </p:sp>
+      <p:pic>
+        <p:nvPicPr>
+          <p:cNvPr id="3" name="Image 0" descr="preencoded.png">    </p:cNvPr>
+          <p:cNvPicPr>
+            <a:picLocks noChangeAspect="1"/>
+          </p:cNvPicPr>
+          <p:nvPr/>
+        </p:nvPicPr>
+        <p:blipFill>
+          <a:blip r:embed="rId1"/>
+          <a:stretch>
+            <a:fillRect/>
+          </a:stretch>
+        </p:blipFill>
+        <p:spPr>
+          <a:xfrm>
+            <a:off x="1060704" y="1280160"/>
+            <a:ext cx="10058400" cy="4297680"/>
+          </a:xfrm>
+          <a:prstGeom prst="rect">
+            <a:avLst/>
+          </a:prstGeom>
+        </p:spPr>
+      </p:pic>
+      <p:sp>
+        <p:nvSpPr>
+          <p:cNvPr id="4" name="Text 1"/>
+          <p:cNvSpPr/>
+          <p:nvPr/>
+        </p:nvSpPr>
+        <p:spPr>
+          <a:xfrm>
+            <a:off x="822960" y="5760720"/>
+            <a:ext cx="10515600" cy="640080"/>
+          </a:xfrm>
+          <a:prstGeom prst="rect">
+            <a:avLst/>
+          </a:prstGeom>
+          <a:noFill/>
+          <a:ln/>
+        </p:spPr>
+        <p:txBody>
+          <a:bodyPr wrap="square" rtlCol="0" anchor="ctr"/>
+          <a:lstStyle/>
+          <a:p>
+            <a:pPr algn="ctr" indent="0" marL="0">
+              <a:buNone/>
+            </a:pPr>
+            <a:r>
+              <a:rPr lang="en-US" sz="1400" i="1" dirty="0">
+                <a:solidFill>
+                  <a:srgbClr val="1B2A3A"/>
+                </a:solidFill>
+                <a:latin typeface="Calibri" pitchFamily="34" charset="0"/>
+                <a:ea typeface="Calibri" pitchFamily="34" charset="-122"/>
+                <a:cs typeface="Calibri" pitchFamily="34" charset="-120"/>
+              </a:rPr>
+              <a:t>Trois expériences suivies dans MLflow : forecasting, pricing, recommandation (paramètres + métriques historisés).</a:t>
+            </a:r>
+            <a:endParaRPr lang="en-US" sz="1400" dirty="0"/>
+          </a:p>
+        </p:txBody>
+      </p:sp>
+    </p:spTree>
+  </p:cSld>
+  <p:clrMapOvr>
+    <a:masterClrMapping/>
+  </p:clrMapOvr>
+</p:sld>
+</file>
+
+<file path=ppt/slides/slide14.xml><?xml version="1.0" encoding="utf-8"?>
+<p:sld xmlns:a="http://schemas.openxmlformats.org/drawingml/2006/main" xmlns:r="http://schemas.openxmlformats.org/officeDocument/2006/relationships" xmlns:p="http://schemas.openxmlformats.org/presentationml/2006/main">
+  <p:cSld name="Slide 14">
+    <p:bg>
+      <p:bgPr>
+        <a:solidFill>
+          <a:srgbClr val="FFFFFF"/>
+        </a:solidFill>
+      </p:bgPr>
+    </p:bg>
+    <p:spTree>
+      <p:nvGrpSpPr>
+        <p:cNvPr id="1" name=""/>
+        <p:cNvGrpSpPr/>
+        <p:nvPr/>
+      </p:nvGrpSpPr>
+      <p:grpSpPr>
+        <a:xfrm>
+          <a:off x="0" y="0"/>
+          <a:ext cx="0" cy="0"/>
+          <a:chOff x="0" y="0"/>
+          <a:chExt cx="0" cy="0"/>
+        </a:xfrm>
+      </p:grpSpPr>
+      <p:sp>
+        <p:nvSpPr>
+          <p:cNvPr id="2" name="Text 0"/>
+          <p:cNvSpPr/>
+          <p:nvPr/>
+        </p:nvSpPr>
+        <p:spPr>
+          <a:xfrm>
+            <a:off x="548640" y="320040"/>
+            <a:ext cx="11064240" cy="822960"/>
+          </a:xfrm>
+          <a:prstGeom prst="rect">
+            <a:avLst/>
+          </a:prstGeom>
+          <a:noFill/>
+          <a:ln/>
+        </p:spPr>
+        <p:txBody>
+          <a:bodyPr wrap="square" rtlCol="0" anchor="ctr"/>
+          <a:lstStyle/>
+          <a:p>
+            <a:pPr indent="0" marL="0">
+              <a:buNone/>
+            </a:pPr>
+            <a:r>
+              <a:rPr lang="en-US" sz="3200" b="1" dirty="0">
+                <a:solidFill>
+                  <a:srgbClr val="003B7A"/>
+                </a:solidFill>
+                <a:latin typeface="Calibri" pitchFamily="34" charset="0"/>
+                <a:ea typeface="Calibri" pitchFamily="34" charset="-122"/>
+                <a:cs typeface="Calibri" pitchFamily="34" charset="-120"/>
+              </a:rPr>
+              <a:t>Conclusion &amp; recommandations</a:t>
+            </a:r>
+            <a:endParaRPr lang="en-US" sz="3200" dirty="0"/>
+          </a:p>
+        </p:txBody>
+      </p:sp>
+      <p:sp>
+        <p:nvSpPr>
+          <p:cNvPr id="3" name="Text 1"/>
+          <p:cNvSpPr/>
+          <p:nvPr/>
+        </p:nvSpPr>
+        <p:spPr>
+          <a:xfrm>
+            <a:off x="822960" y="1737360"/>
+            <a:ext cx="10515600" cy="4114800"/>
+          </a:xfrm>
+          <a:prstGeom prst="rect">
+            <a:avLst/>
+          </a:prstGeom>
+          <a:noFill/>
+          <a:ln/>
+        </p:spPr>
+        <p:txBody>
+          <a:bodyPr wrap="square" rtlCol="0" anchor="t"/>
+          <a:lstStyle/>
+          <a:p>
+            <a:pPr marL="342900" indent="-342900">
+              <a:spcAft>
+                <a:spcPts val="1400"/>
+              </a:spcAft>
+              <a:buSzPct val="100000"/>
+              <a:buChar char="•"/>
+            </a:pPr>
+            <a:r>
+              <a:rPr lang="en-US" sz="1800" dirty="0">
+                <a:solidFill>
+                  <a:srgbClr val="1B2A3A"/>
+                </a:solidFill>
+                <a:latin typeface="Calibri" pitchFamily="34" charset="0"/>
+                <a:ea typeface="Calibri" pitchFamily="34" charset="-122"/>
+                <a:cs typeface="Calibri" pitchFamily="34" charset="-120"/>
+              </a:rPr>
+              <a:t>Une chaîne fonctionnelle de bout en bout — des données brutes à des décisions chiffrées.</a:t>
+            </a:r>
+            <a:endParaRPr lang="en-US" sz="1800" dirty="0"/>
+          </a:p>
+          <a:p>
+            <a:pPr marL="342900" indent="-342900">
+              <a:spcAft>
+                <a:spcPts val="1400"/>
+              </a:spcAft>
+              <a:buSzPct val="100000"/>
+              <a:buChar char="•"/>
+            </a:pPr>
+            <a:r>
+              <a:rPr lang="en-US" sz="1800" dirty="0">
+                <a:solidFill>
+                  <a:srgbClr val="1B2A3A"/>
+                </a:solidFill>
+                <a:latin typeface="Calibri" pitchFamily="34" charset="0"/>
+                <a:ea typeface="Calibri" pitchFamily="34" charset="-122"/>
+                <a:cs typeface="Calibri" pitchFamily="34" charset="-120"/>
+              </a:rPr>
+              <a:t>Trois modèles évalués face à des baselines + une valeur business démontrée.</a:t>
+            </a:r>
+            <a:endParaRPr lang="en-US" sz="1800" dirty="0"/>
+          </a:p>
+          <a:p>
+            <a:pPr marL="342900" indent="-342900">
+              <a:spcAft>
+                <a:spcPts val="1400"/>
+              </a:spcAft>
+              <a:buSzPct val="100000"/>
+              <a:buChar char="•"/>
+            </a:pPr>
+            <a:r>
+              <a:rPr lang="en-US" sz="1800" b="1" dirty="0">
+                <a:solidFill>
+                  <a:srgbClr val="1E8449"/>
+                </a:solidFill>
+                <a:latin typeface="Calibri" pitchFamily="34" charset="0"/>
+                <a:ea typeface="Calibri" pitchFamily="34" charset="-122"/>
+                <a:cs typeface="Calibri" pitchFamily="34" charset="-120"/>
+              </a:rPr>
+              <a:t>Recommandation : GO, en déploiement progressif (pricing → prévision → reco après A/B test), avec monitoring continu.</a:t>
+            </a:r>
+            <a:endParaRPr lang="en-US" sz="1800" dirty="0"/>
+          </a:p>
+          <a:p>
+            <a:pPr marL="342900" indent="-342900">
+              <a:buSzPct val="100000"/>
+              <a:buChar char="•"/>
+            </a:pPr>
+            <a:r>
+              <a:rPr lang="en-US" sz="1800" dirty="0">
+                <a:solidFill>
+                  <a:srgbClr val="1B2A3A"/>
+                </a:solidFill>
+                <a:latin typeface="Calibri" pitchFamily="34" charset="0"/>
+                <a:ea typeface="Calibri" pitchFamily="34" charset="-122"/>
+                <a:cs typeface="Calibri" pitchFamily="34" charset="-120"/>
+              </a:rPr>
+              <a:t>Perspectives : A/B testing, pricing temps réel, modélisation CLTV / churn.</a:t>
+            </a:r>
+            <a:endParaRPr lang="en-US" sz="1800" dirty="0"/>
+          </a:p>
+        </p:txBody>
+      </p:sp>
+    </p:spTree>
+  </p:cSld>
+  <p:clrMapOvr>
+    <a:masterClrMapping/>
+  </p:clrMapOvr>
+</p:sld>
+</file>
+
+<file path=ppt/slides/slide15.xml><?xml version="1.0" encoding="utf-8"?>
+<p:sld xmlns:a="http://schemas.openxmlformats.org/drawingml/2006/main" xmlns:r="http://schemas.openxmlformats.org/officeDocument/2006/relationships" xmlns:p="http://schemas.openxmlformats.org/presentationml/2006/main">
+  <p:cSld name="Slide 15">
+    <p:bg>
+      <p:bgPr>
+        <a:solidFill>
+          <a:srgbClr val="003B7A"/>
+        </a:solidFill>
+      </p:bgPr>
+    </p:bg>
+    <p:spTree>
+      <p:nvGrpSpPr>
+        <p:cNvPr id="1" name=""/>
+        <p:cNvGrpSpPr/>
+        <p:nvPr/>
+      </p:nvGrpSpPr>
+      <p:grpSpPr>
+        <a:xfrm>
+          <a:off x="0" y="0"/>
+          <a:ext cx="0" cy="0"/>
+          <a:chOff x="0" y="0"/>
+          <a:chExt cx="0" cy="0"/>
+        </a:xfrm>
+      </p:grpSpPr>
+      <p:sp>
+        <p:nvSpPr>
           <p:cNvPr id="2" name="Shape 0"/>
           <p:cNvSpPr/>
           <p:nvPr/>
@@ -3469,7 +4285,7 @@
             <a:prstDash val="solid"/>
           </a:ln>
           <a:effectLst>
-            <a:outerShdw blurRad="76200" dist="25400" dir="5400000" algn="bl" rotWithShape="0">
+            <a:outerShdw sx="100000" sy="100000" kx="0" ky="0" algn="bl" rotWithShape="0" blurRad="76200" dist="25400" dir="5400000">
               <a:srgbClr val="9AA7B4">
                 <a:alpha val="35000"/>
               </a:srgbClr>
@@ -3479,14 +4295,14 @@
       </p:sp>
       <p:pic>
         <p:nvPicPr>
-          <p:cNvPr id="3" name="Image 0" descr="preencoded.png"/>
+          <p:cNvPr id="3" name="Image 0" descr="preencoded.png">    </p:cNvPr>
           <p:cNvPicPr>
             <a:picLocks noChangeAspect="1"/>
           </p:cNvPicPr>
           <p:nvPr/>
         </p:nvPicPr>
         <p:blipFill>
-          <a:blip r:embed="rId3"/>
+          <a:blip r:embed="rId1"/>
           <a:stretch>
             <a:fillRect/>
           </a:stretch>
@@ -3522,7 +4338,7 @@
           <a:bodyPr wrap="square" rtlCol="0" anchor="ctr"/>
           <a:lstStyle/>
           <a:p>
-            <a:pPr marL="0" indent="0" algn="ctr">
+            <a:pPr algn="ctr" indent="0" marL="0">
               <a:buNone/>
             </a:pPr>
             <a:r>
@@ -3561,7 +4377,7 @@
           <a:bodyPr wrap="square" rtlCol="0" anchor="ctr"/>
           <a:lstStyle/>
           <a:p>
-            <a:pPr marL="0" indent="0" algn="ctr">
+            <a:pPr algn="ctr" indent="0" marL="0">
               <a:buNone/>
             </a:pPr>
             <a:r>
@@ -3600,7 +4416,7 @@
           <a:bodyPr wrap="square" rtlCol="0" anchor="ctr"/>
           <a:lstStyle/>
           <a:p>
-            <a:pPr marL="0" indent="0" algn="ctr">
+            <a:pPr algn="ctr" indent="0" marL="0">
               <a:buNone/>
             </a:pPr>
             <a:r>
@@ -3634,7 +4450,6 @@
         <a:solidFill>
           <a:srgbClr val="FFFFFF"/>
         </a:solidFill>
-        <a:effectLst/>
       </p:bgPr>
     </p:bg>
     <p:spTree>
@@ -3672,7 +4487,7 @@
           <a:bodyPr wrap="square" rtlCol="0" anchor="ctr"/>
           <a:lstStyle/>
           <a:p>
-            <a:pPr marL="0" indent="0">
+            <a:pPr indent="0" marL="0">
               <a:buNone/>
             </a:pPr>
             <a:r>
@@ -3711,7 +4526,7 @@
           <a:bodyPr wrap="square" rtlCol="0" anchor="ctr"/>
           <a:lstStyle/>
           <a:p>
-            <a:pPr marL="0" indent="0">
+            <a:pPr indent="0" marL="0">
               <a:buNone/>
             </a:pPr>
             <a:r>
@@ -3755,7 +4570,7 @@
             <a:prstDash val="solid"/>
           </a:ln>
           <a:effectLst>
-            <a:outerShdw blurRad="76200" dist="25400" dir="5400000" algn="bl" rotWithShape="0">
+            <a:outerShdw sx="100000" sy="100000" kx="0" ky="0" algn="bl" rotWithShape="0" blurRad="76200" dist="25400" dir="5400000">
               <a:srgbClr val="9AA7B4">
                 <a:alpha val="35000"/>
               </a:srgbClr>
@@ -3784,7 +4599,7 @@
           <a:bodyPr wrap="square" rtlCol="0" anchor="ctr"/>
           <a:lstStyle/>
           <a:p>
-            <a:pPr marL="0" indent="0">
+            <a:pPr indent="0" marL="0">
               <a:buNone/>
             </a:pPr>
             <a:r>
@@ -3823,7 +4638,7 @@
           <a:bodyPr wrap="square" rtlCol="0" anchor="ctr"/>
           <a:lstStyle/>
           <a:p>
-            <a:pPr marL="0" indent="0">
+            <a:pPr indent="0" marL="0">
               <a:buNone/>
             </a:pPr>
             <a:r>
@@ -3867,7 +4682,7 @@
             <a:prstDash val="solid"/>
           </a:ln>
           <a:effectLst>
-            <a:outerShdw blurRad="76200" dist="25400" dir="5400000" algn="bl" rotWithShape="0">
+            <a:outerShdw sx="100000" sy="100000" kx="0" ky="0" algn="bl" rotWithShape="0" blurRad="76200" dist="25400" dir="5400000">
               <a:srgbClr val="9AA7B4">
                 <a:alpha val="35000"/>
               </a:srgbClr>
@@ -3896,7 +4711,7 @@
           <a:bodyPr wrap="square" rtlCol="0" anchor="ctr"/>
           <a:lstStyle/>
           <a:p>
-            <a:pPr marL="0" indent="0">
+            <a:pPr indent="0" marL="0">
               <a:buNone/>
             </a:pPr>
             <a:r>
@@ -3935,7 +4750,7 @@
           <a:bodyPr wrap="square" rtlCol="0" anchor="ctr"/>
           <a:lstStyle/>
           <a:p>
-            <a:pPr marL="0" indent="0">
+            <a:pPr indent="0" marL="0">
               <a:buNone/>
             </a:pPr>
             <a:r>
@@ -3979,7 +4794,7 @@
             <a:prstDash val="solid"/>
           </a:ln>
           <a:effectLst>
-            <a:outerShdw blurRad="76200" dist="25400" dir="5400000" algn="bl" rotWithShape="0">
+            <a:outerShdw sx="100000" sy="100000" kx="0" ky="0" algn="bl" rotWithShape="0" blurRad="76200" dist="25400" dir="5400000">
               <a:srgbClr val="9AA7B4">
                 <a:alpha val="35000"/>
               </a:srgbClr>
@@ -4008,7 +4823,7 @@
           <a:bodyPr wrap="square" rtlCol="0" anchor="ctr"/>
           <a:lstStyle/>
           <a:p>
-            <a:pPr marL="0" indent="0">
+            <a:pPr indent="0" marL="0">
               <a:buNone/>
             </a:pPr>
             <a:r>
@@ -4047,7 +4862,7 @@
           <a:bodyPr wrap="square" rtlCol="0" anchor="ctr"/>
           <a:lstStyle/>
           <a:p>
-            <a:pPr marL="0" indent="0">
+            <a:pPr indent="0" marL="0">
               <a:buNone/>
             </a:pPr>
             <a:r>
@@ -4081,7 +4896,6 @@
         <a:solidFill>
           <a:srgbClr val="FFFFFF"/>
         </a:solidFill>
-        <a:effectLst/>
       </p:bgPr>
     </p:bg>
     <p:spTree>
@@ -4119,7 +4933,7 @@
           <a:bodyPr wrap="square" rtlCol="0" anchor="ctr"/>
           <a:lstStyle/>
           <a:p>
-            <a:pPr marL="0" indent="0">
+            <a:pPr indent="0" marL="0">
               <a:buNone/>
             </a:pPr>
             <a:r>
@@ -4158,7 +4972,7 @@
           <a:bodyPr wrap="square" rtlCol="0" anchor="ctr"/>
           <a:lstStyle/>
           <a:p>
-            <a:pPr marL="0" indent="0">
+            <a:pPr indent="0" marL="0">
               <a:buNone/>
             </a:pPr>
             <a:r>
@@ -4202,7 +5016,7 @@
             <a:prstDash val="solid"/>
           </a:ln>
           <a:effectLst>
-            <a:outerShdw blurRad="76200" dist="25400" dir="5400000" algn="bl" rotWithShape="0">
+            <a:outerShdw sx="100000" sy="100000" kx="0" ky="0" algn="bl" rotWithShape="0" blurRad="76200" dist="25400" dir="5400000">
               <a:srgbClr val="9AA7B4">
                 <a:alpha val="35000"/>
               </a:srgbClr>
@@ -4231,7 +5045,7 @@
           <a:bodyPr wrap="square" lIns="0" tIns="0" rIns="0" bIns="0" rtlCol="0" anchor="ctr"/>
           <a:lstStyle/>
           <a:p>
-            <a:pPr marL="0" indent="0" algn="ctr">
+            <a:pPr algn="ctr" indent="0" marL="0">
               <a:buNone/>
             </a:pPr>
             <a:r>
@@ -4270,7 +5084,7 @@
           <a:bodyPr wrap="square" lIns="0" tIns="0" rIns="0" bIns="0" rtlCol="0" anchor="ctr"/>
           <a:lstStyle/>
           <a:p>
-            <a:pPr marL="0" indent="0" algn="ctr">
+            <a:pPr algn="ctr" indent="0" marL="0">
               <a:buNone/>
             </a:pPr>
             <a:r>
@@ -4287,7 +5101,7 @@
             <a:endParaRPr lang="en-US" sz="1500" dirty="0"/>
           </a:p>
           <a:p>
-            <a:pPr marL="0" indent="0" algn="ctr">
+            <a:pPr algn="ctr" indent="0" marL="0">
               <a:buNone/>
             </a:pPr>
             <a:r>
@@ -4331,7 +5145,7 @@
             <a:prstDash val="solid"/>
           </a:ln>
           <a:effectLst>
-            <a:outerShdw blurRad="76200" dist="25400" dir="5400000" algn="bl" rotWithShape="0">
+            <a:outerShdw sx="100000" sy="100000" kx="0" ky="0" algn="bl" rotWithShape="0" blurRad="76200" dist="25400" dir="5400000">
               <a:srgbClr val="9AA7B4">
                 <a:alpha val="35000"/>
               </a:srgbClr>
@@ -4360,7 +5174,7 @@
           <a:bodyPr wrap="square" lIns="0" tIns="0" rIns="0" bIns="0" rtlCol="0" anchor="ctr"/>
           <a:lstStyle/>
           <a:p>
-            <a:pPr marL="0" indent="0" algn="ctr">
+            <a:pPr algn="ctr" indent="0" marL="0">
               <a:buNone/>
             </a:pPr>
             <a:r>
@@ -4399,7 +5213,7 @@
           <a:bodyPr wrap="square" lIns="0" tIns="0" rIns="0" bIns="0" rtlCol="0" anchor="ctr"/>
           <a:lstStyle/>
           <a:p>
-            <a:pPr marL="0" indent="0" algn="ctr">
+            <a:pPr algn="ctr" indent="0" marL="0">
               <a:buNone/>
             </a:pPr>
             <a:r>
@@ -4416,7 +5230,7 @@
             <a:endParaRPr lang="en-US" sz="1500" dirty="0"/>
           </a:p>
           <a:p>
-            <a:pPr marL="0" indent="0" algn="ctr">
+            <a:pPr algn="ctr" indent="0" marL="0">
               <a:buNone/>
             </a:pPr>
             <a:r>
@@ -4460,7 +5274,7 @@
             <a:prstDash val="solid"/>
           </a:ln>
           <a:effectLst>
-            <a:outerShdw blurRad="76200" dist="25400" dir="5400000" algn="bl" rotWithShape="0">
+            <a:outerShdw sx="100000" sy="100000" kx="0" ky="0" algn="bl" rotWithShape="0" blurRad="76200" dist="25400" dir="5400000">
               <a:srgbClr val="9AA7B4">
                 <a:alpha val="35000"/>
               </a:srgbClr>
@@ -4489,7 +5303,7 @@
           <a:bodyPr wrap="square" lIns="0" tIns="0" rIns="0" bIns="0" rtlCol="0" anchor="ctr"/>
           <a:lstStyle/>
           <a:p>
-            <a:pPr marL="0" indent="0" algn="ctr">
+            <a:pPr algn="ctr" indent="0" marL="0">
               <a:buNone/>
             </a:pPr>
             <a:r>
@@ -4528,7 +5342,7 @@
           <a:bodyPr wrap="square" lIns="0" tIns="0" rIns="0" bIns="0" rtlCol="0" anchor="ctr"/>
           <a:lstStyle/>
           <a:p>
-            <a:pPr marL="0" indent="0" algn="ctr">
+            <a:pPr algn="ctr" indent="0" marL="0">
               <a:buNone/>
             </a:pPr>
             <a:r>
@@ -4545,7 +5359,7 @@
             <a:endParaRPr lang="en-US" sz="1500" dirty="0"/>
           </a:p>
           <a:p>
-            <a:pPr marL="0" indent="0" algn="ctr">
+            <a:pPr algn="ctr" indent="0" marL="0">
               <a:buNone/>
             </a:pPr>
             <a:r>
@@ -4589,7 +5403,7 @@
             <a:prstDash val="solid"/>
           </a:ln>
           <a:effectLst>
-            <a:outerShdw blurRad="76200" dist="25400" dir="5400000" algn="bl" rotWithShape="0">
+            <a:outerShdw sx="100000" sy="100000" kx="0" ky="0" algn="bl" rotWithShape="0" blurRad="76200" dist="25400" dir="5400000">
               <a:srgbClr val="9AA7B4">
                 <a:alpha val="35000"/>
               </a:srgbClr>
@@ -4618,7 +5432,7 @@
           <a:bodyPr wrap="square" lIns="0" tIns="0" rIns="0" bIns="0" rtlCol="0" anchor="ctr"/>
           <a:lstStyle/>
           <a:p>
-            <a:pPr marL="0" indent="0" algn="ctr">
+            <a:pPr algn="ctr" indent="0" marL="0">
               <a:buNone/>
             </a:pPr>
             <a:r>
@@ -4657,7 +5471,7 @@
           <a:bodyPr wrap="square" lIns="0" tIns="0" rIns="0" bIns="0" rtlCol="0" anchor="ctr"/>
           <a:lstStyle/>
           <a:p>
-            <a:pPr marL="0" indent="0" algn="ctr">
+            <a:pPr algn="ctr" indent="0" marL="0">
               <a:buNone/>
             </a:pPr>
             <a:r>
@@ -4674,7 +5488,7 @@
             <a:endParaRPr lang="en-US" sz="1500" dirty="0"/>
           </a:p>
           <a:p>
-            <a:pPr marL="0" indent="0" algn="ctr">
+            <a:pPr algn="ctr" indent="0" marL="0">
               <a:buNone/>
             </a:pPr>
             <a:r>
@@ -4708,7 +5522,6 @@
         <a:solidFill>
           <a:srgbClr val="FFFFFF"/>
         </a:solidFill>
-        <a:effectLst/>
       </p:bgPr>
     </p:bg>
     <p:spTree>
@@ -4746,7 +5559,7 @@
           <a:bodyPr wrap="square" rtlCol="0" anchor="ctr"/>
           <a:lstStyle/>
           <a:p>
-            <a:pPr marL="0" indent="0">
+            <a:pPr indent="0" marL="0">
               <a:buNone/>
             </a:pPr>
             <a:r>
@@ -4785,7 +5598,7 @@
           <a:bodyPr wrap="square" rtlCol="0" anchor="t"/>
           <a:lstStyle/>
           <a:p>
-            <a:pPr marL="0" indent="0">
+            <a:pPr indent="0" marL="0">
               <a:lnSpc>
                 <a:spcPct val="125000"/>
               </a:lnSpc>
@@ -4802,6 +5615,12 @@
               </a:rPr>
               <a:t>Sources</a:t>
             </a:r>
+            <a:pPr indent="0" marL="0">
+              <a:lnSpc>
+                <a:spcPct val="125000"/>
+              </a:lnSpc>
+              <a:buNone/>
+            </a:pPr>
             <a:r>
               <a:rPr lang="en-US" sz="1600" dirty="0">
                 <a:solidFill>
@@ -4811,9 +5630,32 @@
                 <a:ea typeface="Calibri" pitchFamily="34" charset="-122"/>
                 <a:cs typeface="Calibri" pitchFamily="34" charset="-120"/>
               </a:rPr>
-              <a:t> — apps, site, logs de navigation
+              <a:t> — apps, site, logs de navigation</a:t>
+            </a:r>
+            <a:pPr indent="0" marL="0">
+              <a:lnSpc>
+                <a:spcPct val="125000"/>
+              </a:lnSpc>
+              <a:buNone/>
+            </a:pPr>
+            <a:r>
+              <a:rPr lang="en-US" sz="1600" dirty="0">
+                <a:solidFill>
+                  <a:srgbClr val="1B2A3A"/>
+                </a:solidFill>
+                <a:latin typeface="Calibri" pitchFamily="34" charset="0"/>
+                <a:ea typeface="Calibri" pitchFamily="34" charset="-122"/>
+                <a:cs typeface="Calibri" pitchFamily="34" charset="-120"/>
+              </a:rPr>
+              <a:t>
 </a:t>
             </a:r>
+            <a:pPr indent="0" marL="0">
+              <a:lnSpc>
+                <a:spcPct val="125000"/>
+              </a:lnSpc>
+              <a:buNone/>
+            </a:pPr>
             <a:r>
               <a:rPr lang="en-US" sz="1600" b="1" dirty="0">
                 <a:solidFill>
@@ -4825,6 +5667,12 @@
               </a:rPr>
               <a:t>Ingestion</a:t>
             </a:r>
+            <a:pPr indent="0" marL="0">
+              <a:lnSpc>
+                <a:spcPct val="125000"/>
+              </a:lnSpc>
+              <a:buNone/>
+            </a:pPr>
             <a:r>
               <a:rPr lang="en-US" sz="1600" dirty="0">
                 <a:solidFill>
@@ -4834,9 +5682,32 @@
                 <a:ea typeface="Calibri" pitchFamily="34" charset="-122"/>
                 <a:cs typeface="Calibri" pitchFamily="34" charset="-120"/>
               </a:rPr>
-              <a:t> — Kafka (streaming), Spark (batch)
+              <a:t> — Kafka (streaming), Spark (batch)</a:t>
+            </a:r>
+            <a:pPr indent="0" marL="0">
+              <a:lnSpc>
+                <a:spcPct val="125000"/>
+              </a:lnSpc>
+              <a:buNone/>
+            </a:pPr>
+            <a:r>
+              <a:rPr lang="en-US" sz="1600" dirty="0">
+                <a:solidFill>
+                  <a:srgbClr val="1B2A3A"/>
+                </a:solidFill>
+                <a:latin typeface="Calibri" pitchFamily="34" charset="0"/>
+                <a:ea typeface="Calibri" pitchFamily="34" charset="-122"/>
+                <a:cs typeface="Calibri" pitchFamily="34" charset="-120"/>
+              </a:rPr>
+              <a:t>
 </a:t>
             </a:r>
+            <a:pPr indent="0" marL="0">
+              <a:lnSpc>
+                <a:spcPct val="125000"/>
+              </a:lnSpc>
+              <a:buNone/>
+            </a:pPr>
             <a:r>
               <a:rPr lang="en-US" sz="1600" b="1" dirty="0">
                 <a:solidFill>
@@ -4848,6 +5719,12 @@
               </a:rPr>
               <a:t>Stockage</a:t>
             </a:r>
+            <a:pPr indent="0" marL="0">
+              <a:lnSpc>
+                <a:spcPct val="125000"/>
+              </a:lnSpc>
+              <a:buNone/>
+            </a:pPr>
             <a:r>
               <a:rPr lang="en-US" sz="1600" dirty="0">
                 <a:solidFill>
@@ -4857,9 +5734,32 @@
                 <a:ea typeface="Calibri" pitchFamily="34" charset="-122"/>
                 <a:cs typeface="Calibri" pitchFamily="34" charset="-120"/>
               </a:rPr>
-              <a:t> — Data Lake (Parquet) + Warehouse (DuckDB)
+              <a:t> — Data Lake (Parquet) + Warehouse (DuckDB)</a:t>
+            </a:r>
+            <a:pPr indent="0" marL="0">
+              <a:lnSpc>
+                <a:spcPct val="125000"/>
+              </a:lnSpc>
+              <a:buNone/>
+            </a:pPr>
+            <a:r>
+              <a:rPr lang="en-US" sz="1600" dirty="0">
+                <a:solidFill>
+                  <a:srgbClr val="1B2A3A"/>
+                </a:solidFill>
+                <a:latin typeface="Calibri" pitchFamily="34" charset="0"/>
+                <a:ea typeface="Calibri" pitchFamily="34" charset="-122"/>
+                <a:cs typeface="Calibri" pitchFamily="34" charset="-120"/>
+              </a:rPr>
+              <a:t>
 </a:t>
             </a:r>
+            <a:pPr indent="0" marL="0">
+              <a:lnSpc>
+                <a:spcPct val="125000"/>
+              </a:lnSpc>
+              <a:buNone/>
+            </a:pPr>
             <a:r>
               <a:rPr lang="en-US" sz="1600" b="1" dirty="0">
                 <a:solidFill>
@@ -4871,6 +5771,12 @@
               </a:rPr>
               <a:t>Modèles</a:t>
             </a:r>
+            <a:pPr indent="0" marL="0">
+              <a:lnSpc>
+                <a:spcPct val="125000"/>
+              </a:lnSpc>
+              <a:buNone/>
+            </a:pPr>
             <a:r>
               <a:rPr lang="en-US" sz="1600" dirty="0">
                 <a:solidFill>
@@ -4880,9 +5786,32 @@
                 <a:ea typeface="Calibri" pitchFamily="34" charset="-122"/>
                 <a:cs typeface="Calibri" pitchFamily="34" charset="-120"/>
               </a:rPr>
-              <a:t> — prévision, pricing, recommandation
+              <a:t> — prévision, pricing, recommandation</a:t>
+            </a:r>
+            <a:pPr indent="0" marL="0">
+              <a:lnSpc>
+                <a:spcPct val="125000"/>
+              </a:lnSpc>
+              <a:buNone/>
+            </a:pPr>
+            <a:r>
+              <a:rPr lang="en-US" sz="1600" dirty="0">
+                <a:solidFill>
+                  <a:srgbClr val="1B2A3A"/>
+                </a:solidFill>
+                <a:latin typeface="Calibri" pitchFamily="34" charset="0"/>
+                <a:ea typeface="Calibri" pitchFamily="34" charset="-122"/>
+                <a:cs typeface="Calibri" pitchFamily="34" charset="-120"/>
+              </a:rPr>
+              <a:t>
 </a:t>
             </a:r>
+            <a:pPr indent="0" marL="0">
+              <a:lnSpc>
+                <a:spcPct val="125000"/>
+              </a:lnSpc>
+              <a:buNone/>
+            </a:pPr>
             <a:r>
               <a:rPr lang="en-US" sz="1600" b="1" dirty="0">
                 <a:solidFill>
@@ -4894,6 +5823,12 @@
               </a:rPr>
               <a:t>Exposition</a:t>
             </a:r>
+            <a:pPr indent="0" marL="0">
+              <a:lnSpc>
+                <a:spcPct val="125000"/>
+              </a:lnSpc>
+              <a:buNone/>
+            </a:pPr>
             <a:r>
               <a:rPr lang="en-US" sz="1600" dirty="0">
                 <a:solidFill>
@@ -4903,9 +5838,32 @@
                 <a:ea typeface="Calibri" pitchFamily="34" charset="-122"/>
                 <a:cs typeface="Calibri" pitchFamily="34" charset="-120"/>
               </a:rPr>
-              <a:t> — API REST (FastAPI, Docker)
+              <a:t> — API REST (FastAPI, Docker)</a:t>
+            </a:r>
+            <a:pPr indent="0" marL="0">
+              <a:lnSpc>
+                <a:spcPct val="125000"/>
+              </a:lnSpc>
+              <a:buNone/>
+            </a:pPr>
+            <a:r>
+              <a:rPr lang="en-US" sz="1600" dirty="0">
+                <a:solidFill>
+                  <a:srgbClr val="1B2A3A"/>
+                </a:solidFill>
+                <a:latin typeface="Calibri" pitchFamily="34" charset="0"/>
+                <a:ea typeface="Calibri" pitchFamily="34" charset="-122"/>
+                <a:cs typeface="Calibri" pitchFamily="34" charset="-120"/>
+              </a:rPr>
+              <a:t>
 </a:t>
             </a:r>
+            <a:pPr indent="0" marL="0">
+              <a:lnSpc>
+                <a:spcPct val="125000"/>
+              </a:lnSpc>
+              <a:buNone/>
+            </a:pPr>
             <a:r>
               <a:rPr lang="en-US" sz="1600" b="1" dirty="0">
                 <a:solidFill>
@@ -4917,6 +5875,12 @@
               </a:rPr>
               <a:t>Restitution</a:t>
             </a:r>
+            <a:pPr indent="0" marL="0">
+              <a:lnSpc>
+                <a:spcPct val="125000"/>
+              </a:lnSpc>
+              <a:buNone/>
+            </a:pPr>
             <a:r>
               <a:rPr lang="en-US" sz="1600" dirty="0">
                 <a:solidFill>
@@ -4926,9 +5890,32 @@
                 <a:ea typeface="Calibri" pitchFamily="34" charset="-122"/>
                 <a:cs typeface="Calibri" pitchFamily="34" charset="-120"/>
               </a:rPr>
-              <a:t> — dashboard décisionnel (Dash)
+              <a:t> — dashboard décisionnel (Dash)</a:t>
+            </a:r>
+            <a:pPr indent="0" marL="0">
+              <a:lnSpc>
+                <a:spcPct val="125000"/>
+              </a:lnSpc>
+              <a:buNone/>
+            </a:pPr>
+            <a:r>
+              <a:rPr lang="en-US" sz="1600" dirty="0">
+                <a:solidFill>
+                  <a:srgbClr val="1B2A3A"/>
+                </a:solidFill>
+                <a:latin typeface="Calibri" pitchFamily="34" charset="0"/>
+                <a:ea typeface="Calibri" pitchFamily="34" charset="-122"/>
+                <a:cs typeface="Calibri" pitchFamily="34" charset="-120"/>
+              </a:rPr>
+              <a:t>
 </a:t>
             </a:r>
+            <a:pPr indent="0" marL="0">
+              <a:lnSpc>
+                <a:spcPct val="125000"/>
+              </a:lnSpc>
+              <a:buNone/>
+            </a:pPr>
             <a:r>
               <a:rPr lang="en-US" sz="1600" b="1" dirty="0">
                 <a:solidFill>
@@ -4940,6 +5927,12 @@
               </a:rPr>
               <a:t>Transversal</a:t>
             </a:r>
+            <a:pPr indent="0" marL="0">
+              <a:lnSpc>
+                <a:spcPct val="125000"/>
+              </a:lnSpc>
+              <a:buNone/>
+            </a:pPr>
             <a:r>
               <a:rPr lang="en-US" sz="1600" dirty="0">
                 <a:solidFill>
@@ -4957,14 +5950,14 @@
       </p:sp>
       <p:pic>
         <p:nvPicPr>
-          <p:cNvPr id="4" name="Image 0" descr="preencoded.png"/>
+          <p:cNvPr id="4" name="Image 0" descr="preencoded.png">    </p:cNvPr>
           <p:cNvPicPr>
             <a:picLocks noChangeAspect="1"/>
           </p:cNvPicPr>
           <p:nvPr/>
         </p:nvPicPr>
         <p:blipFill>
-          <a:blip r:embed="rId3"/>
+          <a:blip r:embed="rId1"/>
           <a:stretch>
             <a:fillRect/>
           </a:stretch>
@@ -4995,7 +5988,6 @@
         <a:solidFill>
           <a:srgbClr val="FFFFFF"/>
         </a:solidFill>
-        <a:effectLst/>
       </p:bgPr>
     </p:bg>
     <p:spTree>
@@ -5033,7 +6025,7 @@
           <a:bodyPr wrap="square" rtlCol="0" anchor="ctr"/>
           <a:lstStyle/>
           <a:p>
-            <a:pPr marL="0" indent="0">
+            <a:pPr indent="0" marL="0">
               <a:buNone/>
             </a:pPr>
             <a:r>
@@ -5072,7 +6064,7 @@
           <a:bodyPr wrap="square" rtlCol="0" anchor="ctr"/>
           <a:lstStyle/>
           <a:p>
-            <a:pPr marL="0" indent="0">
+            <a:pPr indent="0" marL="0">
               <a:buNone/>
             </a:pPr>
             <a:r>
@@ -5116,7 +6108,7 @@
             <a:prstDash val="solid"/>
           </a:ln>
           <a:effectLst>
-            <a:outerShdw blurRad="76200" dist="25400" dir="5400000" algn="bl" rotWithShape="0">
+            <a:outerShdw sx="100000" sy="100000" kx="0" ky="0" algn="bl" rotWithShape="0" blurRad="76200" dist="25400" dir="5400000">
               <a:srgbClr val="9AA7B4">
                 <a:alpha val="35000"/>
               </a:srgbClr>
@@ -5145,7 +6137,7 @@
           <a:bodyPr wrap="square" lIns="0" tIns="0" rIns="0" bIns="0" rtlCol="0" anchor="ctr"/>
           <a:lstStyle/>
           <a:p>
-            <a:pPr marL="0" indent="0" algn="ctr">
+            <a:pPr algn="ctr" indent="0" marL="0">
               <a:buNone/>
             </a:pPr>
             <a:r>
@@ -5184,7 +6176,7 @@
           <a:bodyPr wrap="square" lIns="0" tIns="0" rIns="0" bIns="0" rtlCol="0" anchor="ctr"/>
           <a:lstStyle/>
           <a:p>
-            <a:pPr marL="0" indent="0" algn="ctr">
+            <a:pPr algn="ctr" indent="0" marL="0">
               <a:buNone/>
             </a:pPr>
             <a:r>
@@ -5201,7 +6193,7 @@
             <a:endParaRPr lang="en-US" sz="1400" dirty="0"/>
           </a:p>
           <a:p>
-            <a:pPr marL="0" indent="0" algn="ctr">
+            <a:pPr algn="ctr" indent="0" marL="0">
               <a:buNone/>
             </a:pPr>
             <a:r>
@@ -5245,7 +6237,7 @@
             <a:prstDash val="solid"/>
           </a:ln>
           <a:effectLst>
-            <a:outerShdw blurRad="76200" dist="25400" dir="5400000" algn="bl" rotWithShape="0">
+            <a:outerShdw sx="100000" sy="100000" kx="0" ky="0" algn="bl" rotWithShape="0" blurRad="76200" dist="25400" dir="5400000">
               <a:srgbClr val="9AA7B4">
                 <a:alpha val="35000"/>
               </a:srgbClr>
@@ -5274,7 +6266,7 @@
           <a:bodyPr wrap="square" lIns="0" tIns="0" rIns="0" bIns="0" rtlCol="0" anchor="ctr"/>
           <a:lstStyle/>
           <a:p>
-            <a:pPr marL="0" indent="0" algn="ctr">
+            <a:pPr algn="ctr" indent="0" marL="0">
               <a:buNone/>
             </a:pPr>
             <a:r>
@@ -5313,7 +6305,7 @@
           <a:bodyPr wrap="square" lIns="0" tIns="0" rIns="0" bIns="0" rtlCol="0" anchor="ctr"/>
           <a:lstStyle/>
           <a:p>
-            <a:pPr marL="0" indent="0" algn="ctr">
+            <a:pPr algn="ctr" indent="0" marL="0">
               <a:buNone/>
             </a:pPr>
             <a:r>
@@ -5357,7 +6349,7 @@
             <a:prstDash val="solid"/>
           </a:ln>
           <a:effectLst>
-            <a:outerShdw blurRad="76200" dist="25400" dir="5400000" algn="bl" rotWithShape="0">
+            <a:outerShdw sx="100000" sy="100000" kx="0" ky="0" algn="bl" rotWithShape="0" blurRad="76200" dist="25400" dir="5400000">
               <a:srgbClr val="9AA7B4">
                 <a:alpha val="35000"/>
               </a:srgbClr>
@@ -5386,7 +6378,7 @@
           <a:bodyPr wrap="square" lIns="0" tIns="0" rIns="0" bIns="0" rtlCol="0" anchor="ctr"/>
           <a:lstStyle/>
           <a:p>
-            <a:pPr marL="0" indent="0" algn="ctr">
+            <a:pPr algn="ctr" indent="0" marL="0">
               <a:buNone/>
             </a:pPr>
             <a:r>
@@ -5425,7 +6417,7 @@
           <a:bodyPr wrap="square" lIns="0" tIns="0" rIns="0" bIns="0" rtlCol="0" anchor="ctr"/>
           <a:lstStyle/>
           <a:p>
-            <a:pPr marL="0" indent="0" algn="ctr">
+            <a:pPr algn="ctr" indent="0" marL="0">
               <a:buNone/>
             </a:pPr>
             <a:r>
@@ -5469,7 +6461,7 @@
             <a:prstDash val="solid"/>
           </a:ln>
           <a:effectLst>
-            <a:outerShdw blurRad="76200" dist="25400" dir="5400000" algn="bl" rotWithShape="0">
+            <a:outerShdw sx="100000" sy="100000" kx="0" ky="0" algn="bl" rotWithShape="0" blurRad="76200" dist="25400" dir="5400000">
               <a:srgbClr val="9AA7B4">
                 <a:alpha val="35000"/>
               </a:srgbClr>
@@ -5498,7 +6490,7 @@
           <a:bodyPr wrap="square" lIns="0" tIns="0" rIns="0" bIns="0" rtlCol="0" anchor="ctr"/>
           <a:lstStyle/>
           <a:p>
-            <a:pPr marL="0" indent="0" algn="ctr">
+            <a:pPr algn="ctr" indent="0" marL="0">
               <a:buNone/>
             </a:pPr>
             <a:r>
@@ -5537,7 +6529,7 @@
           <a:bodyPr wrap="square" lIns="0" tIns="0" rIns="0" bIns="0" rtlCol="0" anchor="ctr"/>
           <a:lstStyle/>
           <a:p>
-            <a:pPr marL="0" indent="0" algn="ctr">
+            <a:pPr algn="ctr" indent="0" marL="0">
               <a:buNone/>
             </a:pPr>
             <a:r>
@@ -5554,7 +6546,7 @@
             <a:endParaRPr lang="en-US" sz="1400" dirty="0"/>
           </a:p>
           <a:p>
-            <a:pPr marL="0" indent="0" algn="ctr">
+            <a:pPr algn="ctr" indent="0" marL="0">
               <a:buNone/>
             </a:pPr>
             <a:r>
@@ -5593,7 +6585,7 @@
           <a:bodyPr wrap="square" rtlCol="0" anchor="ctr"/>
           <a:lstStyle/>
           <a:p>
-            <a:pPr marL="0" indent="0">
+            <a:pPr indent="0" marL="0">
               <a:buNone/>
             </a:pPr>
             <a:r>
@@ -5627,7 +6619,6 @@
         <a:solidFill>
           <a:srgbClr val="FFFFFF"/>
         </a:solidFill>
-        <a:effectLst/>
       </p:bgPr>
     </p:bg>
     <p:spTree>
@@ -5665,7 +6656,7 @@
           <a:bodyPr wrap="square" rtlCol="0" anchor="ctr"/>
           <a:lstStyle/>
           <a:p>
-            <a:pPr marL="0" indent="0">
+            <a:pPr indent="0" marL="0">
               <a:buNone/>
             </a:pPr>
             <a:r>
@@ -5704,7 +6695,7 @@
           <a:bodyPr wrap="square" rtlCol="0" anchor="t"/>
           <a:lstStyle/>
           <a:p>
-            <a:pPr marL="0" indent="0">
+            <a:pPr indent="0" marL="0">
               <a:buNone/>
             </a:pPr>
             <a:r>
@@ -5718,6 +6709,9 @@
               </a:rPr>
               <a:t>Prophet</a:t>
             </a:r>
+            <a:pPr indent="0" marL="0">
+              <a:buNone/>
+            </a:pPr>
             <a:r>
               <a:rPr lang="en-US" sz="1700" dirty="0">
                 <a:solidFill>
@@ -5727,10 +6721,55 @@
                 <a:ea typeface="Calibri" pitchFamily="34" charset="-122"/>
                 <a:cs typeface="Calibri" pitchFamily="34" charset="-120"/>
               </a:rPr>
-              <a:t>, demande quotidienne par catégorie.
-Baseline naïve → Prophet → Prophet enrichi de l'effet promotions.
+              <a:t>, demande quotidienne par catégorie.</a:t>
+            </a:r>
+            <a:pPr indent="0" marL="0">
+              <a:buNone/>
+            </a:pPr>
+            <a:r>
+              <a:rPr lang="en-US" sz="1700" dirty="0">
+                <a:solidFill>
+                  <a:srgbClr val="1B2A3A"/>
+                </a:solidFill>
+                <a:latin typeface="Calibri" pitchFamily="34" charset="0"/>
+                <a:ea typeface="Calibri" pitchFamily="34" charset="-122"/>
+                <a:cs typeface="Calibri" pitchFamily="34" charset="-120"/>
+              </a:rPr>
+              <a:t>
 </a:t>
             </a:r>
+            <a:pPr indent="0" marL="0">
+              <a:buNone/>
+            </a:pPr>
+            <a:r>
+              <a:rPr lang="en-US" sz="1700" dirty="0">
+                <a:solidFill>
+                  <a:srgbClr val="1B2A3A"/>
+                </a:solidFill>
+                <a:latin typeface="Calibri" pitchFamily="34" charset="0"/>
+                <a:ea typeface="Calibri" pitchFamily="34" charset="-122"/>
+                <a:cs typeface="Calibri" pitchFamily="34" charset="-120"/>
+              </a:rPr>
+              <a:t>Baseline naïve → Prophet → Prophet enrichi de l'effet promotions.</a:t>
+            </a:r>
+            <a:pPr indent="0" marL="0">
+              <a:buNone/>
+            </a:pPr>
+            <a:r>
+              <a:rPr lang="en-US" sz="1700" dirty="0">
+                <a:solidFill>
+                  <a:srgbClr val="1B2A3A"/>
+                </a:solidFill>
+                <a:latin typeface="Calibri" pitchFamily="34" charset="0"/>
+                <a:ea typeface="Calibri" pitchFamily="34" charset="-122"/>
+                <a:cs typeface="Calibri" pitchFamily="34" charset="-120"/>
+              </a:rPr>
+              <a:t>
+</a:t>
+            </a:r>
+            <a:pPr indent="0" marL="0">
+              <a:buNone/>
+            </a:pPr>
             <a:r>
               <a:rPr lang="en-US" sz="1700" i="1" dirty="0">
                 <a:solidFill>
@@ -5767,7 +6806,7 @@
           <a:bodyPr wrap="square" lIns="0" tIns="0" rIns="0" bIns="0" rtlCol="0" anchor="ctr"/>
           <a:lstStyle/>
           <a:p>
-            <a:pPr marL="0" indent="0" algn="ctr">
+            <a:pPr algn="ctr" indent="0" marL="0">
               <a:buNone/>
             </a:pPr>
             <a:r>
@@ -5806,7 +6845,7 @@
           <a:bodyPr wrap="square" lIns="0" tIns="0" rIns="0" bIns="0" rtlCol="0" anchor="ctr"/>
           <a:lstStyle/>
           <a:p>
-            <a:pPr marL="0" indent="0" algn="ctr">
+            <a:pPr algn="ctr" indent="0" marL="0">
               <a:buNone/>
             </a:pPr>
             <a:r>
@@ -5826,7 +6865,7 @@
       </p:sp>
       <p:graphicFrame>
         <p:nvGraphicFramePr>
-          <p:cNvPr id="6" name="Chart 0"/>
+          <p:cNvPr id="6" name="Chart 0" descr=""/>
           <p:cNvGraphicFramePr/>
           <p:nvPr/>
         </p:nvGraphicFramePr>
@@ -5834,9 +6873,9 @@
           <a:off x="5669280" y="1554480"/>
           <a:ext cx="5943600" cy="4572000"/>
         </p:xfrm>
-        <a:graphic>
+        <a:graphic xmlns:a="http://schemas.openxmlformats.org/drawingml/2006/main">
           <a:graphicData uri="http://schemas.openxmlformats.org/drawingml/2006/chart">
-            <c:chart xmlns:c="http://schemas.openxmlformats.org/drawingml/2006/chart" xmlns:r="http://schemas.openxmlformats.org/officeDocument/2006/relationships" r:id="rId3"/>
+            <c:chart xmlns:c="http://schemas.openxmlformats.org/drawingml/2006/chart" r:id="rId1"/>
           </a:graphicData>
         </a:graphic>
       </p:graphicFrame>
@@ -5856,7 +6895,6 @@
         <a:solidFill>
           <a:srgbClr val="FFFFFF"/>
         </a:solidFill>
-        <a:effectLst/>
       </p:bgPr>
     </p:bg>
     <p:spTree>
@@ -5894,7 +6932,7 @@
           <a:bodyPr wrap="square" rtlCol="0" anchor="ctr"/>
           <a:lstStyle/>
           <a:p>
-            <a:pPr marL="0" indent="0">
+            <a:pPr indent="0" marL="0">
               <a:buNone/>
             </a:pPr>
             <a:r>
@@ -5933,7 +6971,7 @@
           <a:bodyPr wrap="square" rtlCol="0" anchor="ctr"/>
           <a:lstStyle/>
           <a:p>
-            <a:pPr marL="0" indent="0">
+            <a:pPr indent="0" marL="0">
               <a:buNone/>
             </a:pPr>
             <a:r>
@@ -5947,6 +6985,9 @@
               </a:rPr>
               <a:t>Élasticité-prix estimée via les promotions </a:t>
             </a:r>
+            <a:pPr indent="0" marL="0">
+              <a:buNone/>
+            </a:pPr>
             <a:r>
               <a:rPr lang="en-US" sz="1700" b="1" dirty="0">
                 <a:solidFill>
@@ -5958,6 +6999,9 @@
               </a:rPr>
               <a:t>(≈ −2,5)</a:t>
             </a:r>
+            <a:pPr indent="0" marL="0">
+              <a:buNone/>
+            </a:pPr>
             <a:r>
               <a:rPr lang="en-US" sz="1700" dirty="0">
                 <a:solidFill>
@@ -5999,7 +7043,7 @@
             <a:prstDash val="solid"/>
           </a:ln>
           <a:effectLst>
-            <a:outerShdw blurRad="76200" dist="25400" dir="5400000" algn="bl" rotWithShape="0">
+            <a:outerShdw sx="100000" sy="100000" kx="0" ky="0" algn="bl" rotWithShape="0" blurRad="76200" dist="25400" dir="5400000">
               <a:srgbClr val="9AA7B4">
                 <a:alpha val="35000"/>
               </a:srgbClr>
@@ -6028,7 +7072,7 @@
           <a:bodyPr wrap="square" lIns="0" tIns="0" rIns="0" bIns="0" rtlCol="0" anchor="ctr"/>
           <a:lstStyle/>
           <a:p>
-            <a:pPr marL="0" indent="0" algn="ctr">
+            <a:pPr algn="ctr" indent="0" marL="0">
               <a:buNone/>
             </a:pPr>
             <a:r>
@@ -6067,7 +7111,7 @@
           <a:bodyPr wrap="square" lIns="0" tIns="0" rIns="0" bIns="0" rtlCol="0" anchor="ctr"/>
           <a:lstStyle/>
           <a:p>
-            <a:pPr marL="0" indent="0" algn="ctr">
+            <a:pPr algn="ctr" indent="0" marL="0">
               <a:buNone/>
             </a:pPr>
             <a:r>
@@ -6084,7 +7128,7 @@
             <a:endParaRPr lang="en-US" sz="1400" dirty="0"/>
           </a:p>
           <a:p>
-            <a:pPr marL="0" indent="0" algn="ctr">
+            <a:pPr algn="ctr" indent="0" marL="0">
               <a:buNone/>
             </a:pPr>
             <a:r>
@@ -6123,7 +7167,7 @@
           <a:bodyPr wrap="square" lIns="0" tIns="0" rIns="0" bIns="0" rtlCol="0" anchor="ctr"/>
           <a:lstStyle/>
           <a:p>
-            <a:pPr marL="0" indent="0" algn="ctr">
+            <a:pPr algn="ctr" indent="0" marL="0">
               <a:buNone/>
             </a:pPr>
             <a:r>
@@ -6167,7 +7211,7 @@
             <a:prstDash val="solid"/>
           </a:ln>
           <a:effectLst>
-            <a:outerShdw blurRad="76200" dist="25400" dir="5400000" algn="bl" rotWithShape="0">
+            <a:outerShdw sx="100000" sy="100000" kx="0" ky="0" algn="bl" rotWithShape="0" blurRad="76200" dist="25400" dir="5400000">
               <a:srgbClr val="9AA7B4">
                 <a:alpha val="35000"/>
               </a:srgbClr>
@@ -6196,7 +7240,7 @@
           <a:bodyPr wrap="square" lIns="0" tIns="0" rIns="0" bIns="0" rtlCol="0" anchor="ctr"/>
           <a:lstStyle/>
           <a:p>
-            <a:pPr marL="0" indent="0" algn="ctr">
+            <a:pPr algn="ctr" indent="0" marL="0">
               <a:buNone/>
             </a:pPr>
             <a:r>
@@ -6235,7 +7279,7 @@
           <a:bodyPr wrap="square" lIns="0" tIns="0" rIns="0" bIns="0" rtlCol="0" anchor="ctr"/>
           <a:lstStyle/>
           <a:p>
-            <a:pPr marL="0" indent="0" algn="ctr">
+            <a:pPr algn="ctr" indent="0" marL="0">
               <a:buNone/>
             </a:pPr>
             <a:r>
@@ -6274,7 +7318,7 @@
           <a:bodyPr wrap="square" rtlCol="0" anchor="ctr"/>
           <a:lstStyle/>
           <a:p>
-            <a:pPr marL="0" indent="0">
+            <a:pPr indent="0" marL="0">
               <a:buNone/>
             </a:pPr>
             <a:r>
@@ -6308,7 +7352,6 @@
         <a:solidFill>
           <a:srgbClr val="FFFFFF"/>
         </a:solidFill>
-        <a:effectLst/>
       </p:bgPr>
     </p:bg>
     <p:spTree>
@@ -6346,7 +7389,7 @@
           <a:bodyPr wrap="square" rtlCol="0" anchor="ctr"/>
           <a:lstStyle/>
           <a:p>
-            <a:pPr marL="0" indent="0">
+            <a:pPr indent="0" marL="0">
               <a:buNone/>
             </a:pPr>
             <a:r>
@@ -6385,7 +7428,7 @@
           <a:bodyPr wrap="square" rtlCol="0" anchor="ctr"/>
           <a:lstStyle/>
           <a:p>
-            <a:pPr marL="0" indent="0">
+            <a:pPr indent="0" marL="0">
               <a:buNone/>
             </a:pPr>
             <a:r>
@@ -6405,7 +7448,7 @@
       </p:sp>
       <p:graphicFrame>
         <p:nvGraphicFramePr>
-          <p:cNvPr id="4" name="Chart 0"/>
+          <p:cNvPr id="4" name="Chart 0" descr=""/>
           <p:cNvGraphicFramePr/>
           <p:nvPr/>
         </p:nvGraphicFramePr>
@@ -6413,9 +7456,9 @@
           <a:off x="548640" y="1737360"/>
           <a:ext cx="6400800" cy="4480560"/>
         </p:xfrm>
-        <a:graphic>
+        <a:graphic xmlns:a="http://schemas.openxmlformats.org/drawingml/2006/main">
           <a:graphicData uri="http://schemas.openxmlformats.org/drawingml/2006/chart">
-            <c:chart xmlns:c="http://schemas.openxmlformats.org/drawingml/2006/chart" xmlns:r="http://schemas.openxmlformats.org/officeDocument/2006/relationships" r:id="rId3"/>
+            <c:chart xmlns:c="http://schemas.openxmlformats.org/drawingml/2006/chart" r:id="rId1"/>
           </a:graphicData>
         </a:graphic>
       </p:graphicFrame>
@@ -6445,7 +7488,7 @@
             <a:prstDash val="solid"/>
           </a:ln>
           <a:effectLst>
-            <a:outerShdw blurRad="76200" dist="25400" dir="5400000" algn="bl" rotWithShape="0">
+            <a:outerShdw sx="100000" sy="100000" kx="0" ky="0" algn="bl" rotWithShape="0" blurRad="76200" dist="25400" dir="5400000">
               <a:srgbClr val="9AA7B4">
                 <a:alpha val="35000"/>
               </a:srgbClr>
@@ -6474,7 +7517,7 @@
           <a:bodyPr wrap="square" rtlCol="0" anchor="t"/>
           <a:lstStyle/>
           <a:p>
-            <a:pPr marL="0" indent="0">
+            <a:pPr indent="0" marL="0">
               <a:buNone/>
             </a:pPr>
             <a:r>
@@ -6491,7 +7534,7 @@
             <a:endParaRPr lang="en-US" sz="1800" dirty="0"/>
           </a:p>
           <a:p>
-            <a:pPr marL="0" indent="0">
+            <a:pPr indent="0" marL="0">
               <a:buNone/>
             </a:pPr>
             <a:r>
@@ -6509,7 +7552,7 @@
             <a:endParaRPr lang="en-US" sz="1800" dirty="0"/>
           </a:p>
           <a:p>
-            <a:pPr marL="0" indent="0">
+            <a:pPr indent="0" marL="0">
               <a:buNone/>
             </a:pPr>
             <a:r>
@@ -6526,7 +7569,7 @@
             <a:endParaRPr lang="en-US" sz="1800" dirty="0"/>
           </a:p>
           <a:p>
-            <a:pPr marL="0" indent="0">
+            <a:pPr indent="0" marL="0">
               <a:buNone/>
             </a:pPr>
             <a:r>
@@ -6544,7 +7587,7 @@
             <a:endParaRPr lang="en-US" sz="1800" dirty="0"/>
           </a:p>
           <a:p>
-            <a:pPr marL="0" indent="0">
+            <a:pPr indent="0" marL="0">
               <a:buNone/>
             </a:pPr>
             <a:r>
@@ -6578,7 +7621,6 @@
         <a:solidFill>
           <a:srgbClr val="FFFFFF"/>
         </a:solidFill>
-        <a:effectLst/>
       </p:bgPr>
     </p:bg>
     <p:spTree>
@@ -6616,7 +7658,7 @@
           <a:bodyPr wrap="square" rtlCol="0" anchor="ctr"/>
           <a:lstStyle/>
           <a:p>
-            <a:pPr marL="0" indent="0">
+            <a:pPr indent="0" marL="0">
               <a:buNone/>
             </a:pPr>
             <a:r>
@@ -6660,7 +7702,7 @@
             <a:prstDash val="solid"/>
           </a:ln>
           <a:effectLst>
-            <a:outerShdw blurRad="76200" dist="25400" dir="5400000" algn="bl" rotWithShape="0">
+            <a:outerShdw sx="100000" sy="100000" kx="0" ky="0" algn="bl" rotWithShape="0" blurRad="76200" dist="25400" dir="5400000">
               <a:srgbClr val="9AA7B4">
                 <a:alpha val="35000"/>
               </a:srgbClr>
@@ -6689,7 +7731,7 @@
           <a:bodyPr wrap="square" rtlCol="0" anchor="ctr"/>
           <a:lstStyle/>
           <a:p>
-            <a:pPr marL="0" indent="0">
+            <a:pPr indent="0" marL="0">
               <a:buNone/>
             </a:pPr>
             <a:r>
@@ -6728,7 +7770,7 @@
           <a:bodyPr wrap="square" rtlCol="0" anchor="ctr"/>
           <a:lstStyle/>
           <a:p>
-            <a:pPr marL="0" indent="0">
+            <a:pPr indent="0" marL="0">
               <a:buNone/>
             </a:pPr>
             <a:r>
@@ -6772,7 +7814,7 @@
             <a:prstDash val="solid"/>
           </a:ln>
           <a:effectLst>
-            <a:outerShdw blurRad="76200" dist="25400" dir="5400000" algn="bl" rotWithShape="0">
+            <a:outerShdw sx="100000" sy="100000" kx="0" ky="0" algn="bl" rotWithShape="0" blurRad="76200" dist="25400" dir="5400000">
               <a:srgbClr val="9AA7B4">
                 <a:alpha val="35000"/>
               </a:srgbClr>
@@ -6801,7 +7843,7 @@
           <a:bodyPr wrap="square" rtlCol="0" anchor="ctr"/>
           <a:lstStyle/>
           <a:p>
-            <a:pPr marL="0" indent="0">
+            <a:pPr indent="0" marL="0">
               <a:buNone/>
             </a:pPr>
             <a:r>
@@ -6840,7 +7882,7 @@
           <a:bodyPr wrap="square" rtlCol="0" anchor="ctr"/>
           <a:lstStyle/>
           <a:p>
-            <a:pPr marL="0" indent="0">
+            <a:pPr indent="0" marL="0">
               <a:buNone/>
             </a:pPr>
             <a:r>
@@ -6884,7 +7926,7 @@
             <a:prstDash val="solid"/>
           </a:ln>
           <a:effectLst>
-            <a:outerShdw blurRad="76200" dist="25400" dir="5400000" algn="bl" rotWithShape="0">
+            <a:outerShdw sx="100000" sy="100000" kx="0" ky="0" algn="bl" rotWithShape="0" blurRad="76200" dist="25400" dir="5400000">
               <a:srgbClr val="9AA7B4">
                 <a:alpha val="35000"/>
               </a:srgbClr>
@@ -6913,7 +7955,7 @@
           <a:bodyPr wrap="square" rtlCol="0" anchor="ctr"/>
           <a:lstStyle/>
           <a:p>
-            <a:pPr marL="0" indent="0">
+            <a:pPr indent="0" marL="0">
               <a:buNone/>
             </a:pPr>
             <a:r>
@@ -6952,7 +7994,7 @@
           <a:bodyPr wrap="square" rtlCol="0" anchor="ctr"/>
           <a:lstStyle/>
           <a:p>
-            <a:pPr marL="0" indent="0">
+            <a:pPr indent="0" marL="0">
               <a:buNone/>
             </a:pPr>
             <a:r>
@@ -7271,299 +8313,4 @@
     </a:ext>
   </a:extLst>
 </a:theme>
-</file>
-
-<file path=ppt/theme/theme2.xml><?xml version="1.0" encoding="utf-8"?>
-<a:theme xmlns:a="http://schemas.openxmlformats.org/drawingml/2006/main" name="Thème Office">
-  <a:themeElements>
-    <a:clrScheme name="Office">
-      <a:dk1>
-        <a:sysClr val="windowText" lastClr="000000"/>
-      </a:dk1>
-      <a:lt1>
-        <a:sysClr val="window" lastClr="FFFFFF"/>
-      </a:lt1>
-      <a:dk2>
-        <a:srgbClr val="44546A"/>
-      </a:dk2>
-      <a:lt2>
-        <a:srgbClr val="E7E6E6"/>
-      </a:lt2>
-      <a:accent1>
-        <a:srgbClr val="4472C4"/>
-      </a:accent1>
-      <a:accent2>
-        <a:srgbClr val="ED7D31"/>
-      </a:accent2>
-      <a:accent3>
-        <a:srgbClr val="A5A5A5"/>
-      </a:accent3>
-      <a:accent4>
-        <a:srgbClr val="FFC000"/>
-      </a:accent4>
-      <a:accent5>
-        <a:srgbClr val="5B9BD5"/>
-      </a:accent5>
-      <a:accent6>
-        <a:srgbClr val="70AD47"/>
-      </a:accent6>
-      <a:hlink>
-        <a:srgbClr val="0563C1"/>
-      </a:hlink>
-      <a:folHlink>
-        <a:srgbClr val="954F72"/>
-      </a:folHlink>
-    </a:clrScheme>
-    <a:fontScheme name="Office">
-      <a:majorFont>
-        <a:latin typeface="Calibri Light" panose="020F0302020204030204"/>
-        <a:ea typeface=""/>
-        <a:cs typeface=""/>
-        <a:font script="Jpan" typeface="游ゴシック Light"/>
-        <a:font script="Hang" typeface="맑은 고딕"/>
-        <a:font script="Hans" typeface="等线 Light"/>
-        <a:font script="Hant" typeface="新細明體"/>
-        <a:font script="Arab" typeface="Times New Roman"/>
-        <a:font script="Hebr" typeface="Times New Roman"/>
-        <a:font script="Thai" typeface="Angsana New"/>
-        <a:font script="Ethi" typeface="Nyala"/>
-        <a:font script="Beng" typeface="Vrinda"/>
-        <a:font script="Gujr" typeface="Shruti"/>
-        <a:font script="Khmr" typeface="MoolBoran"/>
-        <a:font script="Knda" typeface="Tunga"/>
-        <a:font script="Guru" typeface="Raavi"/>
-        <a:font script="Cans" typeface="Euphemia"/>
-        <a:font script="Cher" typeface="Plantagenet Cherokee"/>
-        <a:font script="Yiii" typeface="Microsoft Yi Baiti"/>
-        <a:font script="Tibt" typeface="Microsoft Himalaya"/>
-        <a:font script="Thaa" typeface="MV Boli"/>
-        <a:font script="Deva" typeface="Mangal"/>
-        <a:font script="Telu" typeface="Gautami"/>
-        <a:font script="Taml" typeface="Latha"/>
-        <a:font script="Syrc" typeface="Estrangelo Edessa"/>
-        <a:font script="Orya" typeface="Kalinga"/>
-        <a:font script="Mlym" typeface="Kartika"/>
-        <a:font script="Laoo" typeface="DokChampa"/>
-        <a:font script="Sinh" typeface="Iskoola Pota"/>
-        <a:font script="Mong" typeface="Mongolian Baiti"/>
-        <a:font script="Viet" typeface="Times New Roman"/>
-        <a:font script="Uigh" typeface="Microsoft Uighur"/>
-        <a:font script="Geor" typeface="Sylfaen"/>
-        <a:font script="Armn" typeface="Arial"/>
-        <a:font script="Bugi" typeface="Leelawadee UI"/>
-        <a:font script="Bopo" typeface="Microsoft JhengHei"/>
-        <a:font script="Java" typeface="Javanese Text"/>
-        <a:font script="Lisu" typeface="Segoe UI"/>
-        <a:font script="Mymr" typeface="Myanmar Text"/>
-        <a:font script="Nkoo" typeface="Ebrima"/>
-        <a:font script="Olck" typeface="Nirmala UI"/>
-        <a:font script="Osma" typeface="Ebrima"/>
-        <a:font script="Phag" typeface="Phagspa"/>
-        <a:font script="Syrn" typeface="Estrangelo Edessa"/>
-        <a:font script="Syrj" typeface="Estrangelo Edessa"/>
-        <a:font script="Syre" typeface="Estrangelo Edessa"/>
-        <a:font script="Sora" typeface="Nirmala UI"/>
-        <a:font script="Tale" typeface="Microsoft Tai Le"/>
-        <a:font script="Talu" typeface="Microsoft New Tai Lue"/>
-        <a:font script="Tfng" typeface="Ebrima"/>
-      </a:majorFont>
-      <a:minorFont>
-        <a:latin typeface="Calibri" panose="020F0502020204030204"/>
-        <a:ea typeface=""/>
-        <a:cs typeface=""/>
-        <a:font script="Jpan" typeface="游ゴシック"/>
-        <a:font script="Hang" typeface="맑은 고딕"/>
-        <a:font script="Hans" typeface="等线"/>
-        <a:font script="Hant" typeface="新細明體"/>
-        <a:font script="Arab" typeface="Arial"/>
-        <a:font script="Hebr" typeface="Arial"/>
-        <a:font script="Thai" typeface="Cordia New"/>
-        <a:font script="Ethi" typeface="Nyala"/>
-        <a:font script="Beng" typeface="Vrinda"/>
-        <a:font script="Gujr" typeface="Shruti"/>
-        <a:font script="Khmr" typeface="DaunPenh"/>
-        <a:font script="Knda" typeface="Tunga"/>
-        <a:font script="Guru" typeface="Raavi"/>
-        <a:font script="Cans" typeface="Euphemia"/>
-        <a:font script="Cher" typeface="Plantagenet Cherokee"/>
-        <a:font script="Yiii" typeface="Microsoft Yi Baiti"/>
-        <a:font script="Tibt" typeface="Microsoft Himalaya"/>
-        <a:font script="Thaa" typeface="MV Boli"/>
-        <a:font script="Deva" typeface="Mangal"/>
-        <a:font script="Telu" typeface="Gautami"/>
-        <a:font script="Taml" typeface="Latha"/>
-        <a:font script="Syrc" typeface="Estrangelo Edessa"/>
-        <a:font script="Orya" typeface="Kalinga"/>
-        <a:font script="Mlym" typeface="Kartika"/>
-        <a:font script="Laoo" typeface="DokChampa"/>
-        <a:font script="Sinh" typeface="Iskoola Pota"/>
-        <a:font script="Mong" typeface="Mongolian Baiti"/>
-        <a:font script="Viet" typeface="Arial"/>
-        <a:font script="Uigh" typeface="Microsoft Uighur"/>
-        <a:font script="Geor" typeface="Sylfaen"/>
-        <a:font script="Armn" typeface="Arial"/>
-        <a:font script="Bugi" typeface="Leelawadee UI"/>
-        <a:font script="Bopo" typeface="Microsoft JhengHei"/>
-        <a:font script="Java" typeface="Javanese Text"/>
-        <a:font script="Lisu" typeface="Segoe UI"/>
-        <a:font script="Mymr" typeface="Myanmar Text"/>
-        <a:font script="Nkoo" typeface="Ebrima"/>
-        <a:font script="Olck" typeface="Nirmala UI"/>
-        <a:font script="Osma" typeface="Ebrima"/>
-        <a:font script="Phag" typeface="Phagspa"/>
-        <a:font script="Syrn" typeface="Estrangelo Edessa"/>
-        <a:font script="Syrj" typeface="Estrangelo Edessa"/>
-        <a:font script="Syre" typeface="Estrangelo Edessa"/>
-        <a:font script="Sora" typeface="Nirmala UI"/>
-        <a:font script="Tale" typeface="Microsoft Tai Le"/>
-        <a:font script="Talu" typeface="Microsoft New Tai Lue"/>
-        <a:font script="Tfng" typeface="Ebrima"/>
-      </a:minorFont>
-    </a:fontScheme>
-    <a:fmtScheme name="Office">
-      <a:fillStyleLst>
-        <a:solidFill>
-          <a:schemeClr val="phClr"/>
-        </a:solidFill>
-        <a:gradFill rotWithShape="1">
-          <a:gsLst>
-            <a:gs pos="0">
-              <a:schemeClr val="phClr">
-                <a:lumMod val="110000"/>
-                <a:satMod val="105000"/>
-                <a:tint val="67000"/>
-              </a:schemeClr>
-            </a:gs>
-            <a:gs pos="50000">
-              <a:schemeClr val="phClr">
-                <a:lumMod val="105000"/>
-                <a:satMod val="103000"/>
-                <a:tint val="73000"/>
-              </a:schemeClr>
-            </a:gs>
-            <a:gs pos="100000">
-              <a:schemeClr val="phClr">
-                <a:lumMod val="105000"/>
-                <a:satMod val="109000"/>
-                <a:tint val="81000"/>
-              </a:schemeClr>
-            </a:gs>
-          </a:gsLst>
-          <a:lin ang="5400000" scaled="0"/>
-        </a:gradFill>
-        <a:gradFill rotWithShape="1">
-          <a:gsLst>
-            <a:gs pos="0">
-              <a:schemeClr val="phClr">
-                <a:satMod val="103000"/>
-                <a:lumMod val="102000"/>
-                <a:tint val="94000"/>
-              </a:schemeClr>
-            </a:gs>
-            <a:gs pos="50000">
-              <a:schemeClr val="phClr">
-                <a:satMod val="110000"/>
-                <a:lumMod val="100000"/>
-                <a:shade val="100000"/>
-              </a:schemeClr>
-            </a:gs>
-            <a:gs pos="100000">
-              <a:schemeClr val="phClr">
-                <a:lumMod val="99000"/>
-                <a:satMod val="120000"/>
-                <a:shade val="78000"/>
-              </a:schemeClr>
-            </a:gs>
-          </a:gsLst>
-          <a:lin ang="5400000" scaled="0"/>
-        </a:gradFill>
-      </a:fillStyleLst>
-      <a:lnStyleLst>
-        <a:ln w="6350" cap="flat" cmpd="sng" algn="ctr">
-          <a:solidFill>
-            <a:schemeClr val="phClr"/>
-          </a:solidFill>
-          <a:prstDash val="solid"/>
-          <a:miter lim="800000"/>
-        </a:ln>
-        <a:ln w="12700" cap="flat" cmpd="sng" algn="ctr">
-          <a:solidFill>
-            <a:schemeClr val="phClr"/>
-          </a:solidFill>
-          <a:prstDash val="solid"/>
-          <a:miter lim="800000"/>
-        </a:ln>
-        <a:ln w="19050" cap="flat" cmpd="sng" algn="ctr">
-          <a:solidFill>
-            <a:schemeClr val="phClr"/>
-          </a:solidFill>
-          <a:prstDash val="solid"/>
-          <a:miter lim="800000"/>
-        </a:ln>
-      </a:lnStyleLst>
-      <a:effectStyleLst>
-        <a:effectStyle>
-          <a:effectLst/>
-        </a:effectStyle>
-        <a:effectStyle>
-          <a:effectLst/>
-        </a:effectStyle>
-        <a:effectStyle>
-          <a:effectLst>
-            <a:outerShdw blurRad="57150" dist="19050" dir="5400000" algn="ctr" rotWithShape="0">
-              <a:srgbClr val="000000">
-                <a:alpha val="63000"/>
-              </a:srgbClr>
-            </a:outerShdw>
-          </a:effectLst>
-        </a:effectStyle>
-      </a:effectStyleLst>
-      <a:bgFillStyleLst>
-        <a:solidFill>
-          <a:schemeClr val="phClr"/>
-        </a:solidFill>
-        <a:solidFill>
-          <a:schemeClr val="phClr">
-            <a:tint val="95000"/>
-            <a:satMod val="170000"/>
-          </a:schemeClr>
-        </a:solidFill>
-        <a:gradFill rotWithShape="1">
-          <a:gsLst>
-            <a:gs pos="0">
-              <a:schemeClr val="phClr">
-                <a:tint val="93000"/>
-                <a:satMod val="150000"/>
-                <a:shade val="98000"/>
-                <a:lumMod val="102000"/>
-              </a:schemeClr>
-            </a:gs>
-            <a:gs pos="50000">
-              <a:schemeClr val="phClr">
-                <a:tint val="98000"/>
-                <a:satMod val="130000"/>
-                <a:shade val="90000"/>
-                <a:lumMod val="103000"/>
-              </a:schemeClr>
-            </a:gs>
-            <a:gs pos="100000">
-              <a:schemeClr val="phClr">
-                <a:shade val="63000"/>
-                <a:satMod val="120000"/>
-              </a:schemeClr>
-            </a:gs>
-          </a:gsLst>
-          <a:lin ang="5400000" scaled="0"/>
-        </a:gradFill>
-      </a:bgFillStyleLst>
-    </a:fmtScheme>
-  </a:themeElements>
-  <a:objectDefaults/>
-  <a:extraClrSchemeLst/>
-  <a:extLst>
-    <a:ext uri="{05A4C25C-085E-4340-85A3-A5531E510DB2}">
-      <thm15:themeFamily xmlns:thm15="http://schemas.microsoft.com/office/thememl/2012/main" name="Office Theme" id="{62F939B6-93AF-4DB8-9C6B-D6C7DFDC589F}" vid="{4A3C46E8-61CC-4603-A589-7422A47A8E4A}"/>
-    </a:ext>
-  </a:extLst>
-</a:theme>
 </file>
</xml_diff>